<commit_message>
Adicionando power point para apresentação do trabalho semestral
</commit_message>
<xml_diff>
--- a/Jogo da velha - Everton Lourenço.pptx
+++ b/Jogo da velha - Everton Lourenço.pptx
@@ -18,21 +18,22 @@
     <p:sldId id="266" r:id="rId16"/>
     <p:sldId id="267" r:id="rId17"/>
     <p:sldId id="268" r:id="rId18"/>
+    <p:sldId id="269" r:id="rId19"/>
   </p:sldIdLst>
   <p:sldSz cx="18288000" cy="10287000"/>
   <p:notesSz cx="6858000" cy="9144000"/>
   <p:embeddedFontLst>
     <p:embeddedFont>
       <p:font typeface="Aliens and Cow" charset="1" panose="00000000000000000000"/>
-      <p:regular r:id="rId19"/>
+      <p:regular r:id="rId20"/>
     </p:embeddedFont>
     <p:embeddedFont>
       <p:font typeface="Garet" charset="1" panose="00000000000000000000"/>
-      <p:regular r:id="rId20"/>
+      <p:regular r:id="rId21"/>
     </p:embeddedFont>
     <p:embeddedFont>
       <p:font typeface="Garet Bold" charset="1" panose="00000000000000000000"/>
-      <p:regular r:id="rId21"/>
+      <p:regular r:id="rId22"/>
     </p:embeddedFont>
   </p:embeddedFontLst>
   <p:defaultTextStyle>
@@ -4047,6 +4048,651 @@
         </p:nvGrpSpPr>
         <p:grpSpPr>
           <a:xfrm rot="0">
+            <a:off x="-28575" y="-144677"/>
+            <a:ext cx="16574915" cy="9445770"/>
+            <a:chOff x="0" y="0"/>
+            <a:chExt cx="22099887" cy="12594360"/>
+          </a:xfrm>
+        </p:grpSpPr>
+        <p:pic>
+          <p:nvPicPr>
+            <p:cNvPr name="Picture 8" id="8"/>
+            <p:cNvPicPr>
+              <a:picLocks noChangeAspect="true"/>
+            </p:cNvPicPr>
+            <p:nvPr/>
+          </p:nvPicPr>
+          <p:blipFill>
+            <a:blip r:embed="rId8"/>
+            <a:srcRect l="0" t="3437" r="0" b="3437"/>
+            <a:stretch>
+              <a:fillRect/>
+            </a:stretch>
+          </p:blipFill>
+          <p:spPr>
+            <a:xfrm flipH="false" flipV="false">
+              <a:off x="0" y="0"/>
+              <a:ext cx="22099887" cy="12594360"/>
+            </a:xfrm>
+            <a:prstGeom prst="rect">
+              <a:avLst/>
+            </a:prstGeom>
+          </p:spPr>
+        </p:pic>
+      </p:grpSp>
+      <p:sp>
+        <p:nvSpPr>
+          <p:cNvPr name="Freeform 9" id="9"/>
+          <p:cNvSpPr/>
+          <p:nvPr/>
+        </p:nvSpPr>
+        <p:spPr>
+          <a:xfrm flipH="false" flipV="false" rot="0">
+            <a:off x="-1607678" y="-4352204"/>
+            <a:ext cx="19702881" cy="4713230"/>
+          </a:xfrm>
+          <a:custGeom>
+            <a:avLst/>
+            <a:gdLst/>
+            <a:ahLst/>
+            <a:cxnLst/>
+            <a:rect r="r" b="b" t="t" l="l"/>
+            <a:pathLst>
+              <a:path h="4713230" w="19702881">
+                <a:moveTo>
+                  <a:pt x="0" y="0"/>
+                </a:moveTo>
+                <a:lnTo>
+                  <a:pt x="19702881" y="0"/>
+                </a:lnTo>
+                <a:lnTo>
+                  <a:pt x="19702881" y="4713230"/>
+                </a:lnTo>
+                <a:lnTo>
+                  <a:pt x="0" y="4713230"/>
+                </a:lnTo>
+                <a:lnTo>
+                  <a:pt x="0" y="0"/>
+                </a:lnTo>
+                <a:close/>
+              </a:path>
+            </a:pathLst>
+          </a:custGeom>
+          <a:blipFill>
+            <a:blip r:embed="rId9"/>
+            <a:stretch>
+              <a:fillRect l="-650" t="-60057" r="0" b="-60057"/>
+            </a:stretch>
+          </a:blipFill>
+        </p:spPr>
+      </p:sp>
+      <p:sp>
+        <p:nvSpPr>
+          <p:cNvPr name="Freeform 10" id="10"/>
+          <p:cNvSpPr/>
+          <p:nvPr/>
+        </p:nvSpPr>
+        <p:spPr>
+          <a:xfrm flipH="false" flipV="false" rot="0">
+            <a:off x="14941755" y="-64804"/>
+            <a:ext cx="19702881" cy="9921734"/>
+          </a:xfrm>
+          <a:custGeom>
+            <a:avLst/>
+            <a:gdLst/>
+            <a:ahLst/>
+            <a:cxnLst/>
+            <a:rect r="r" b="b" t="t" l="l"/>
+            <a:pathLst>
+              <a:path h="9921734" w="19702881">
+                <a:moveTo>
+                  <a:pt x="0" y="0"/>
+                </a:moveTo>
+                <a:lnTo>
+                  <a:pt x="19702880" y="0"/>
+                </a:lnTo>
+                <a:lnTo>
+                  <a:pt x="19702880" y="9921735"/>
+                </a:lnTo>
+                <a:lnTo>
+                  <a:pt x="0" y="9921735"/>
+                </a:lnTo>
+                <a:lnTo>
+                  <a:pt x="0" y="0"/>
+                </a:lnTo>
+                <a:close/>
+              </a:path>
+            </a:pathLst>
+          </a:custGeom>
+          <a:blipFill>
+            <a:blip r:embed="rId9"/>
+            <a:stretch>
+              <a:fillRect l="-16615" t="-37522" r="-15759" b="0"/>
+            </a:stretch>
+          </a:blipFill>
+        </p:spPr>
+      </p:sp>
+      <p:sp>
+        <p:nvSpPr>
+          <p:cNvPr name="TextBox 11" id="11"/>
+          <p:cNvSpPr txBox="true"/>
+          <p:nvPr/>
+        </p:nvSpPr>
+        <p:spPr>
+          <a:xfrm rot="0">
+            <a:off x="9435193" y="2007081"/>
+            <a:ext cx="8951203" cy="7849850"/>
+          </a:xfrm>
+          <a:prstGeom prst="rect">
+            <a:avLst/>
+          </a:prstGeom>
+        </p:spPr>
+        <p:txBody>
+          <a:bodyPr anchor="t" rtlCol="false" tIns="0" lIns="0" bIns="0" rIns="0">
+            <a:spAutoFit/>
+          </a:bodyPr>
+          <a:lstStyle/>
+          <a:p>
+            <a:pPr algn="l">
+              <a:lnSpc>
+                <a:spcPts val="3896"/>
+              </a:lnSpc>
+            </a:pPr>
+            <a:r>
+              <a:rPr lang="en-US" sz="2597" b="true">
+                <a:solidFill>
+                  <a:srgbClr val="FFFFFF"/>
+                </a:solidFill>
+                <a:latin typeface="Garet Bold"/>
+                <a:ea typeface="Garet Bold"/>
+                <a:cs typeface="Garet Bold"/>
+                <a:sym typeface="Garet Bold"/>
+              </a:rPr>
+              <a:t>          Conferindo se o jogo foi ganho na horizontal:</a:t>
+            </a:r>
+          </a:p>
+          <a:p>
+            <a:pPr algn="l" marL="560824" indent="-280412" lvl="1">
+              <a:lnSpc>
+                <a:spcPts val="3896"/>
+              </a:lnSpc>
+              <a:buFont typeface="Arial"/>
+              <a:buChar char="•"/>
+            </a:pPr>
+            <a:r>
+              <a:rPr lang="en-US" b="true" sz="2597">
+                <a:solidFill>
+                  <a:srgbClr val="FFFFFF"/>
+                </a:solidFill>
+                <a:latin typeface="Garet Bold"/>
+                <a:ea typeface="Garet Bold"/>
+                <a:cs typeface="Garet Bold"/>
+                <a:sym typeface="Garet Bold"/>
+              </a:rPr>
+              <a:t>Inicializa com “count = 0”</a:t>
+            </a:r>
+          </a:p>
+          <a:p>
+            <a:pPr algn="l" marL="560824" indent="-280412" lvl="1">
+              <a:lnSpc>
+                <a:spcPts val="3896"/>
+              </a:lnSpc>
+              <a:buFont typeface="Arial"/>
+              <a:buChar char="•"/>
+            </a:pPr>
+            <a:r>
+              <a:rPr lang="en-US" b="true" sz="2597">
+                <a:solidFill>
+                  <a:srgbClr val="FFFFFF"/>
+                </a:solidFill>
+                <a:latin typeface="Garet Bold"/>
+                <a:ea typeface="Garet Bold"/>
+                <a:cs typeface="Garet Bold"/>
+                <a:sym typeface="Garet Bold"/>
+              </a:rPr>
+              <a:t>Se o número de “count” for do tamanho da matriz na horizontal, significa que o jogo foi ganho e encerra o loop 1</a:t>
+            </a:r>
+          </a:p>
+          <a:p>
+            <a:pPr algn="l" marL="560824" indent="-280412" lvl="1">
+              <a:lnSpc>
+                <a:spcPts val="3896"/>
+              </a:lnSpc>
+              <a:buFont typeface="Arial"/>
+              <a:buChar char="•"/>
+            </a:pPr>
+            <a:r>
+              <a:rPr lang="en-US" b="true" sz="2597">
+                <a:solidFill>
+                  <a:srgbClr val="FFFFFF"/>
+                </a:solidFill>
+                <a:latin typeface="Garet Bold"/>
+                <a:ea typeface="Garet Bold"/>
+                <a:cs typeface="Garet Bold"/>
+                <a:sym typeface="Garet Bold"/>
+              </a:rPr>
+              <a:t>Senão, inicia novamente “count” com zero e entra no segundo “for”</a:t>
+            </a:r>
+          </a:p>
+          <a:p>
+            <a:pPr algn="l" marL="560824" indent="-280412" lvl="1">
+              <a:lnSpc>
+                <a:spcPts val="3896"/>
+              </a:lnSpc>
+              <a:buFont typeface="Arial"/>
+              <a:buChar char="•"/>
+            </a:pPr>
+            <a:r>
+              <a:rPr lang="en-US" b="true" sz="2597">
+                <a:solidFill>
+                  <a:srgbClr val="FFFFFF"/>
+                </a:solidFill>
+                <a:latin typeface="Garet Bold"/>
+                <a:ea typeface="Garet Bold"/>
+                <a:cs typeface="Garet Bold"/>
+                <a:sym typeface="Garet Bold"/>
+              </a:rPr>
+              <a:t>Enquanto existir o “num” dentro da matriz, acrescenta +1 em “count”</a:t>
+            </a:r>
+          </a:p>
+          <a:p>
+            <a:pPr algn="l" marL="560824" indent="-280412" lvl="1">
+              <a:lnSpc>
+                <a:spcPts val="3896"/>
+              </a:lnSpc>
+              <a:buFont typeface="Arial"/>
+              <a:buChar char="•"/>
+            </a:pPr>
+            <a:r>
+              <a:rPr lang="en-US" b="true" sz="2597">
+                <a:solidFill>
+                  <a:srgbClr val="FFFFFF"/>
+                </a:solidFill>
+                <a:latin typeface="Garet Bold"/>
+                <a:ea typeface="Garet Bold"/>
+                <a:cs typeface="Garet Bold"/>
+                <a:sym typeface="Garet Bold"/>
+              </a:rPr>
+              <a:t>Se pular para a segunda linha da matriz e “count” for do tamanho da matriz, então o jogo foi ganho</a:t>
+            </a:r>
+          </a:p>
+          <a:p>
+            <a:pPr algn="l" marL="560824" indent="-280412" lvl="1">
+              <a:lnSpc>
+                <a:spcPts val="3896"/>
+              </a:lnSpc>
+              <a:buFont typeface="Arial"/>
+              <a:buChar char="•"/>
+            </a:pPr>
+            <a:r>
+              <a:rPr lang="en-US" b="true" sz="2597">
+                <a:solidFill>
+                  <a:srgbClr val="FFFFFF"/>
+                </a:solidFill>
+                <a:latin typeface="Garet Bold"/>
+                <a:ea typeface="Garet Bold"/>
+                <a:cs typeface="Garet Bold"/>
+                <a:sym typeface="Garet Bold"/>
+              </a:rPr>
+              <a:t>Se “count” não for do tamanho da matriz, “count” volta a ser zero e reinicia a contagem</a:t>
+            </a:r>
+          </a:p>
+          <a:p>
+            <a:pPr algn="l" marL="560824" indent="-280412" lvl="1">
+              <a:lnSpc>
+                <a:spcPts val="3896"/>
+              </a:lnSpc>
+              <a:spcBef>
+                <a:spcPct val="0"/>
+              </a:spcBef>
+              <a:buFont typeface="Arial"/>
+              <a:buChar char="•"/>
+            </a:pPr>
+            <a:r>
+              <a:rPr lang="en-US" b="true" sz="2597">
+                <a:solidFill>
+                  <a:srgbClr val="FFFFFF"/>
+                </a:solidFill>
+                <a:latin typeface="Garet Bold"/>
+                <a:ea typeface="Garet Bold"/>
+                <a:cs typeface="Garet Bold"/>
+                <a:sym typeface="Garet Bold"/>
+              </a:rPr>
+              <a:t>retorna true ou false para indicar se o jogo encerrou</a:t>
+            </a:r>
+          </a:p>
+        </p:txBody>
+      </p:sp>
+      <p:sp>
+        <p:nvSpPr>
+          <p:cNvPr name="Freeform 12" id="12"/>
+          <p:cNvSpPr/>
+          <p:nvPr/>
+        </p:nvSpPr>
+        <p:spPr>
+          <a:xfrm flipH="false" flipV="false" rot="0">
+            <a:off x="-1414881" y="8896479"/>
+            <a:ext cx="19702881" cy="9921734"/>
+          </a:xfrm>
+          <a:custGeom>
+            <a:avLst/>
+            <a:gdLst/>
+            <a:ahLst/>
+            <a:cxnLst/>
+            <a:rect r="r" b="b" t="t" l="l"/>
+            <a:pathLst>
+              <a:path h="9921734" w="19702881">
+                <a:moveTo>
+                  <a:pt x="0" y="0"/>
+                </a:moveTo>
+                <a:lnTo>
+                  <a:pt x="19702881" y="0"/>
+                </a:lnTo>
+                <a:lnTo>
+                  <a:pt x="19702881" y="9921734"/>
+                </a:lnTo>
+                <a:lnTo>
+                  <a:pt x="0" y="9921734"/>
+                </a:lnTo>
+                <a:lnTo>
+                  <a:pt x="0" y="0"/>
+                </a:lnTo>
+                <a:close/>
+              </a:path>
+            </a:pathLst>
+          </a:custGeom>
+          <a:blipFill>
+            <a:blip r:embed="rId9"/>
+            <a:stretch>
+              <a:fillRect l="-16615" t="-37522" r="-15759" b="0"/>
+            </a:stretch>
+          </a:blipFill>
+        </p:spPr>
+      </p:sp>
+    </p:spTree>
+  </p:cSld>
+  <p:clrMapOvr>
+    <a:masterClrMapping/>
+  </p:clrMapOvr>
+</p:sld>
+</file>
+
+<file path=ppt/slides/slide11.xml><?xml version="1.0" encoding="utf-8"?>
+<p:sld xmlns:p="http://schemas.openxmlformats.org/presentationml/2006/main" xmlns:a="http://schemas.openxmlformats.org/drawingml/2006/main" xmlns:r="http://schemas.openxmlformats.org/officeDocument/2006/relationships">
+  <p:cSld>
+    <p:spTree>
+      <p:nvGrpSpPr>
+        <p:cNvPr id="1" name=""/>
+        <p:cNvGrpSpPr/>
+        <p:nvPr/>
+      </p:nvGrpSpPr>
+      <p:grpSpPr>
+        <a:xfrm>
+          <a:off x="0" y="0"/>
+          <a:ext cx="0" cy="0"/>
+          <a:chOff x="0" y="0"/>
+          <a:chExt cx="0" cy="0"/>
+        </a:xfrm>
+      </p:grpSpPr>
+      <p:sp>
+        <p:nvSpPr>
+          <p:cNvPr name="Freeform 2" id="2"/>
+          <p:cNvSpPr/>
+          <p:nvPr/>
+        </p:nvSpPr>
+        <p:spPr>
+          <a:xfrm flipH="false" flipV="false" rot="0">
+            <a:off x="0" y="0"/>
+            <a:ext cx="18288000" cy="10287000"/>
+          </a:xfrm>
+          <a:custGeom>
+            <a:avLst/>
+            <a:gdLst/>
+            <a:ahLst/>
+            <a:cxnLst/>
+            <a:rect r="r" b="b" t="t" l="l"/>
+            <a:pathLst>
+              <a:path h="10287000" w="18288000">
+                <a:moveTo>
+                  <a:pt x="0" y="0"/>
+                </a:moveTo>
+                <a:lnTo>
+                  <a:pt x="18288000" y="0"/>
+                </a:lnTo>
+                <a:lnTo>
+                  <a:pt x="18288000" y="10287000"/>
+                </a:lnTo>
+                <a:lnTo>
+                  <a:pt x="0" y="10287000"/>
+                </a:lnTo>
+                <a:lnTo>
+                  <a:pt x="0" y="0"/>
+                </a:lnTo>
+                <a:close/>
+              </a:path>
+            </a:pathLst>
+          </a:custGeom>
+          <a:blipFill>
+            <a:blip r:embed="rId2"/>
+            <a:stretch>
+              <a:fillRect l="-8647" t="-18123" r="-6133" b="-85931"/>
+            </a:stretch>
+          </a:blipFill>
+        </p:spPr>
+      </p:sp>
+      <p:sp>
+        <p:nvSpPr>
+          <p:cNvPr name="Freeform 3" id="3" descr="Orange Blur Circle Illustration"/>
+          <p:cNvSpPr/>
+          <p:nvPr/>
+        </p:nvSpPr>
+        <p:spPr>
+          <a:xfrm flipH="false" flipV="false" rot="0">
+            <a:off x="15450107" y="-97052"/>
+            <a:ext cx="8883833" cy="8883833"/>
+          </a:xfrm>
+          <a:custGeom>
+            <a:avLst/>
+            <a:gdLst/>
+            <a:ahLst/>
+            <a:cxnLst/>
+            <a:rect r="r" b="b" t="t" l="l"/>
+            <a:pathLst>
+              <a:path h="8883833" w="8883833">
+                <a:moveTo>
+                  <a:pt x="0" y="0"/>
+                </a:moveTo>
+                <a:lnTo>
+                  <a:pt x="8883833" y="0"/>
+                </a:lnTo>
+                <a:lnTo>
+                  <a:pt x="8883833" y="8883833"/>
+                </a:lnTo>
+                <a:lnTo>
+                  <a:pt x="0" y="8883833"/>
+                </a:lnTo>
+                <a:lnTo>
+                  <a:pt x="0" y="0"/>
+                </a:lnTo>
+                <a:close/>
+              </a:path>
+            </a:pathLst>
+          </a:custGeom>
+          <a:blipFill>
+            <a:blip r:embed="rId3">
+              <a:alphaModFix amt="26000"/>
+              <a:extLst>
+                <a:ext uri="{96DAC541-7B7A-43D3-8B79-37D633B846F1}">
+                  <asvg:svgBlip xmlns:asvg="http://schemas.microsoft.com/office/drawing/2016/SVG/main" r:embed="rId4"/>
+                </a:ext>
+              </a:extLst>
+            </a:blip>
+            <a:stretch>
+              <a:fillRect l="0" t="0" r="0" b="0"/>
+            </a:stretch>
+          </a:blipFill>
+        </p:spPr>
+      </p:sp>
+      <p:sp>
+        <p:nvSpPr>
+          <p:cNvPr name="Freeform 4" id="4" descr="70's Groovy Wavy Pattern"/>
+          <p:cNvSpPr/>
+          <p:nvPr/>
+        </p:nvSpPr>
+        <p:spPr>
+          <a:xfrm flipH="false" flipV="false" rot="0">
+            <a:off x="0" y="56747"/>
+            <a:ext cx="8708490" cy="1141958"/>
+          </a:xfrm>
+          <a:custGeom>
+            <a:avLst/>
+            <a:gdLst/>
+            <a:ahLst/>
+            <a:cxnLst/>
+            <a:rect r="r" b="b" t="t" l="l"/>
+            <a:pathLst>
+              <a:path h="1141958" w="8708490">
+                <a:moveTo>
+                  <a:pt x="0" y="0"/>
+                </a:moveTo>
+                <a:lnTo>
+                  <a:pt x="8708490" y="0"/>
+                </a:lnTo>
+                <a:lnTo>
+                  <a:pt x="8708490" y="1141958"/>
+                </a:lnTo>
+                <a:lnTo>
+                  <a:pt x="0" y="1141958"/>
+                </a:lnTo>
+                <a:lnTo>
+                  <a:pt x="0" y="0"/>
+                </a:lnTo>
+                <a:close/>
+              </a:path>
+            </a:pathLst>
+          </a:custGeom>
+          <a:blipFill>
+            <a:blip r:embed="rId5">
+              <a:alphaModFix amt="9999"/>
+              <a:extLst>
+                <a:ext uri="{96DAC541-7B7A-43D3-8B79-37D633B846F1}">
+                  <asvg:svgBlip xmlns:asvg="http://schemas.microsoft.com/office/drawing/2016/SVG/main" r:embed="rId6"/>
+                </a:ext>
+              </a:extLst>
+            </a:blip>
+            <a:stretch>
+              <a:fillRect l="-1768" t="0" r="0" b="-680339"/>
+            </a:stretch>
+          </a:blipFill>
+        </p:spPr>
+      </p:sp>
+      <p:sp>
+        <p:nvSpPr>
+          <p:cNvPr name="Freeform 5" id="5" descr="Orange Blur Circle Illustration"/>
+          <p:cNvSpPr/>
+          <p:nvPr/>
+        </p:nvSpPr>
+        <p:spPr>
+          <a:xfrm flipH="false" flipV="false" rot="0">
+            <a:off x="-6049594" y="-97052"/>
+            <a:ext cx="8883833" cy="8883833"/>
+          </a:xfrm>
+          <a:custGeom>
+            <a:avLst/>
+            <a:gdLst/>
+            <a:ahLst/>
+            <a:cxnLst/>
+            <a:rect r="r" b="b" t="t" l="l"/>
+            <a:pathLst>
+              <a:path h="8883833" w="8883833">
+                <a:moveTo>
+                  <a:pt x="0" y="0"/>
+                </a:moveTo>
+                <a:lnTo>
+                  <a:pt x="8883833" y="0"/>
+                </a:lnTo>
+                <a:lnTo>
+                  <a:pt x="8883833" y="8883833"/>
+                </a:lnTo>
+                <a:lnTo>
+                  <a:pt x="0" y="8883833"/>
+                </a:lnTo>
+                <a:lnTo>
+                  <a:pt x="0" y="0"/>
+                </a:lnTo>
+                <a:close/>
+              </a:path>
+            </a:pathLst>
+          </a:custGeom>
+          <a:blipFill>
+            <a:blip r:embed="rId3">
+              <a:alphaModFix amt="26000"/>
+              <a:extLst>
+                <a:ext uri="{96DAC541-7B7A-43D3-8B79-37D633B846F1}">
+                  <asvg:svgBlip xmlns:asvg="http://schemas.microsoft.com/office/drawing/2016/SVG/main" r:embed="rId4"/>
+                </a:ext>
+              </a:extLst>
+            </a:blip>
+            <a:stretch>
+              <a:fillRect l="0" t="0" r="0" b="0"/>
+            </a:stretch>
+          </a:blipFill>
+        </p:spPr>
+      </p:sp>
+      <p:sp>
+        <p:nvSpPr>
+          <p:cNvPr name="Freeform 6" id="6"/>
+          <p:cNvSpPr/>
+          <p:nvPr/>
+        </p:nvSpPr>
+        <p:spPr>
+          <a:xfrm flipH="false" flipV="false" rot="-8291044">
+            <a:off x="14252994" y="-2820751"/>
+            <a:ext cx="7684417" cy="5907396"/>
+          </a:xfrm>
+          <a:custGeom>
+            <a:avLst/>
+            <a:gdLst/>
+            <a:ahLst/>
+            <a:cxnLst/>
+            <a:rect r="r" b="b" t="t" l="l"/>
+            <a:pathLst>
+              <a:path h="5907396" w="7684417">
+                <a:moveTo>
+                  <a:pt x="0" y="0"/>
+                </a:moveTo>
+                <a:lnTo>
+                  <a:pt x="7684418" y="0"/>
+                </a:lnTo>
+                <a:lnTo>
+                  <a:pt x="7684418" y="5907396"/>
+                </a:lnTo>
+                <a:lnTo>
+                  <a:pt x="0" y="5907396"/>
+                </a:lnTo>
+                <a:lnTo>
+                  <a:pt x="0" y="0"/>
+                </a:lnTo>
+                <a:close/>
+              </a:path>
+            </a:pathLst>
+          </a:custGeom>
+          <a:blipFill>
+            <a:blip r:embed="rId7"/>
+            <a:stretch>
+              <a:fillRect l="0" t="0" r="0" b="0"/>
+            </a:stretch>
+          </a:blipFill>
+        </p:spPr>
+      </p:sp>
+      <p:grpSp>
+        <p:nvGrpSpPr>
+          <p:cNvPr name="Group 7" id="7"/>
+          <p:cNvGrpSpPr/>
+          <p:nvPr/>
+        </p:nvGrpSpPr>
+        <p:grpSpPr>
+          <a:xfrm rot="0">
             <a:off x="-290306" y="-2227685"/>
             <a:ext cx="16574915" cy="9445770"/>
             <a:chOff x="0" y="0"/>
@@ -4304,7 +4950,7 @@
 </p:sld>
 </file>
 
-<file path=ppt/slides/slide11.xml><?xml version="1.0" encoding="utf-8"?>
+<file path=ppt/slides/slide12.xml><?xml version="1.0" encoding="utf-8"?>
 <p:sld xmlns:p="http://schemas.openxmlformats.org/presentationml/2006/main" xmlns:a="http://schemas.openxmlformats.org/drawingml/2006/main" xmlns:r="http://schemas.openxmlformats.org/officeDocument/2006/relationships">
   <p:cSld>
     <p:spTree>
@@ -4842,7 +5488,7 @@
 </p:sld>
 </file>
 
-<file path=ppt/slides/slide12.xml><?xml version="1.0" encoding="utf-8"?>
+<file path=ppt/slides/slide13.xml><?xml version="1.0" encoding="utf-8"?>
 <p:sld xmlns:p="http://schemas.openxmlformats.org/presentationml/2006/main" xmlns:a="http://schemas.openxmlformats.org/drawingml/2006/main" xmlns:r="http://schemas.openxmlformats.org/officeDocument/2006/relationships">
   <p:cSld>
     <p:spTree>
@@ -5294,7 +5940,7 @@
 </p:sld>
 </file>
 
-<file path=ppt/slides/slide13.xml><?xml version="1.0" encoding="utf-8"?>
+<file path=ppt/slides/slide14.xml><?xml version="1.0" encoding="utf-8"?>
 <p:sld xmlns:p="http://schemas.openxmlformats.org/presentationml/2006/main" xmlns:a="http://schemas.openxmlformats.org/drawingml/2006/main" xmlns:r="http://schemas.openxmlformats.org/officeDocument/2006/relationships">
   <p:cSld>
     <p:spTree>
@@ -7404,6 +8050,460 @@
         </p:nvGrpSpPr>
         <p:grpSpPr>
           <a:xfrm rot="0">
+            <a:off x="0" y="-1913797"/>
+            <a:ext cx="21058894" cy="7936380"/>
+            <a:chOff x="0" y="0"/>
+            <a:chExt cx="28078525" cy="10581841"/>
+          </a:xfrm>
+        </p:grpSpPr>
+        <p:pic>
+          <p:nvPicPr>
+            <p:cNvPr name="Picture 8" id="8"/>
+            <p:cNvPicPr>
+              <a:picLocks noChangeAspect="true"/>
+            </p:cNvPicPr>
+            <p:nvPr/>
+          </p:nvPicPr>
+          <p:blipFill>
+            <a:blip r:embed="rId8"/>
+            <a:srcRect l="3398" t="0" r="3398" b="0"/>
+            <a:stretch>
+              <a:fillRect/>
+            </a:stretch>
+          </p:blipFill>
+          <p:spPr>
+            <a:xfrm flipH="false" flipV="false">
+              <a:off x="0" y="0"/>
+              <a:ext cx="28078525" cy="10581841"/>
+            </a:xfrm>
+            <a:prstGeom prst="rect">
+              <a:avLst/>
+            </a:prstGeom>
+          </p:spPr>
+        </p:pic>
+      </p:grpSp>
+      <p:sp>
+        <p:nvSpPr>
+          <p:cNvPr name="Freeform 9" id="9"/>
+          <p:cNvSpPr/>
+          <p:nvPr/>
+        </p:nvSpPr>
+        <p:spPr>
+          <a:xfrm flipH="false" flipV="false" rot="0">
+            <a:off x="-1414881" y="5665825"/>
+            <a:ext cx="19702881" cy="12506334"/>
+          </a:xfrm>
+          <a:custGeom>
+            <a:avLst/>
+            <a:gdLst/>
+            <a:ahLst/>
+            <a:cxnLst/>
+            <a:rect r="r" b="b" t="t" l="l"/>
+            <a:pathLst>
+              <a:path h="12506334" w="19702881">
+                <a:moveTo>
+                  <a:pt x="0" y="0"/>
+                </a:moveTo>
+                <a:lnTo>
+                  <a:pt x="19702881" y="0"/>
+                </a:lnTo>
+                <a:lnTo>
+                  <a:pt x="19702881" y="12506334"/>
+                </a:lnTo>
+                <a:lnTo>
+                  <a:pt x="0" y="12506334"/>
+                </a:lnTo>
+                <a:lnTo>
+                  <a:pt x="0" y="0"/>
+                </a:lnTo>
+                <a:close/>
+              </a:path>
+            </a:pathLst>
+          </a:custGeom>
+          <a:blipFill>
+            <a:blip r:embed="rId9"/>
+            <a:stretch>
+              <a:fillRect l="-16615" t="-9101" r="-15759" b="0"/>
+            </a:stretch>
+          </a:blipFill>
+        </p:spPr>
+      </p:sp>
+      <p:sp>
+        <p:nvSpPr>
+          <p:cNvPr name="Freeform 10" id="10"/>
+          <p:cNvSpPr/>
+          <p:nvPr/>
+        </p:nvSpPr>
+        <p:spPr>
+          <a:xfrm flipH="false" flipV="false" rot="0">
+            <a:off x="-707440" y="-9294008"/>
+            <a:ext cx="19702881" cy="9921734"/>
+          </a:xfrm>
+          <a:custGeom>
+            <a:avLst/>
+            <a:gdLst/>
+            <a:ahLst/>
+            <a:cxnLst/>
+            <a:rect r="r" b="b" t="t" l="l"/>
+            <a:pathLst>
+              <a:path h="9921734" w="19702881">
+                <a:moveTo>
+                  <a:pt x="0" y="0"/>
+                </a:moveTo>
+                <a:lnTo>
+                  <a:pt x="19702880" y="0"/>
+                </a:lnTo>
+                <a:lnTo>
+                  <a:pt x="19702880" y="9921734"/>
+                </a:lnTo>
+                <a:lnTo>
+                  <a:pt x="0" y="9921734"/>
+                </a:lnTo>
+                <a:lnTo>
+                  <a:pt x="0" y="0"/>
+                </a:lnTo>
+                <a:close/>
+              </a:path>
+            </a:pathLst>
+          </a:custGeom>
+          <a:blipFill>
+            <a:blip r:embed="rId9"/>
+            <a:stretch>
+              <a:fillRect l="-16615" t="-37522" r="-15759" b="0"/>
+            </a:stretch>
+          </a:blipFill>
+        </p:spPr>
+      </p:sp>
+      <p:sp>
+        <p:nvSpPr>
+          <p:cNvPr name="TextBox 11" id="11"/>
+          <p:cNvSpPr txBox="true"/>
+          <p:nvPr/>
+        </p:nvSpPr>
+        <p:spPr>
+          <a:xfrm rot="0">
+            <a:off x="5775775" y="6469972"/>
+            <a:ext cx="11095862" cy="1582835"/>
+          </a:xfrm>
+          <a:prstGeom prst="rect">
+            <a:avLst/>
+          </a:prstGeom>
+        </p:spPr>
+        <p:txBody>
+          <a:bodyPr anchor="t" rtlCol="false" tIns="0" lIns="0" bIns="0" rIns="0">
+            <a:spAutoFit/>
+          </a:bodyPr>
+          <a:lstStyle/>
+          <a:p>
+            <a:pPr algn="l" marL="930496" indent="-465248" lvl="1">
+              <a:lnSpc>
+                <a:spcPts val="6464"/>
+              </a:lnSpc>
+              <a:spcBef>
+                <a:spcPct val="0"/>
+              </a:spcBef>
+              <a:buFont typeface="Arial"/>
+              <a:buChar char="•"/>
+            </a:pPr>
+            <a:r>
+              <a:rPr lang="en-US" b="true" sz="4309">
+                <a:solidFill>
+                  <a:srgbClr val="FFFFFF"/>
+                </a:solidFill>
+                <a:latin typeface="Garet Bold"/>
+                <a:ea typeface="Garet Bold"/>
+                <a:cs typeface="Garet Bold"/>
+                <a:sym typeface="Garet Bold"/>
+              </a:rPr>
+              <a:t>While fica em loop enquanto o jogo não for encerrado</a:t>
+            </a:r>
+          </a:p>
+        </p:txBody>
+      </p:sp>
+    </p:spTree>
+  </p:cSld>
+  <p:clrMapOvr>
+    <a:masterClrMapping/>
+  </p:clrMapOvr>
+</p:sld>
+</file>
+
+<file path=ppt/slides/slide6.xml><?xml version="1.0" encoding="utf-8"?>
+<p:sld xmlns:p="http://schemas.openxmlformats.org/presentationml/2006/main" xmlns:a="http://schemas.openxmlformats.org/drawingml/2006/main" xmlns:r="http://schemas.openxmlformats.org/officeDocument/2006/relationships">
+  <p:cSld>
+    <p:spTree>
+      <p:nvGrpSpPr>
+        <p:cNvPr id="1" name=""/>
+        <p:cNvGrpSpPr/>
+        <p:nvPr/>
+      </p:nvGrpSpPr>
+      <p:grpSpPr>
+        <a:xfrm>
+          <a:off x="0" y="0"/>
+          <a:ext cx="0" cy="0"/>
+          <a:chOff x="0" y="0"/>
+          <a:chExt cx="0" cy="0"/>
+        </a:xfrm>
+      </p:grpSpPr>
+      <p:sp>
+        <p:nvSpPr>
+          <p:cNvPr name="Freeform 2" id="2"/>
+          <p:cNvSpPr/>
+          <p:nvPr/>
+        </p:nvSpPr>
+        <p:spPr>
+          <a:xfrm flipH="false" flipV="false" rot="0">
+            <a:off x="0" y="0"/>
+            <a:ext cx="18288000" cy="10287000"/>
+          </a:xfrm>
+          <a:custGeom>
+            <a:avLst/>
+            <a:gdLst/>
+            <a:ahLst/>
+            <a:cxnLst/>
+            <a:rect r="r" b="b" t="t" l="l"/>
+            <a:pathLst>
+              <a:path h="10287000" w="18288000">
+                <a:moveTo>
+                  <a:pt x="0" y="0"/>
+                </a:moveTo>
+                <a:lnTo>
+                  <a:pt x="18288000" y="0"/>
+                </a:lnTo>
+                <a:lnTo>
+                  <a:pt x="18288000" y="10287000"/>
+                </a:lnTo>
+                <a:lnTo>
+                  <a:pt x="0" y="10287000"/>
+                </a:lnTo>
+                <a:lnTo>
+                  <a:pt x="0" y="0"/>
+                </a:lnTo>
+                <a:close/>
+              </a:path>
+            </a:pathLst>
+          </a:custGeom>
+          <a:blipFill>
+            <a:blip r:embed="rId2"/>
+            <a:stretch>
+              <a:fillRect l="-8647" t="-18123" r="-6133" b="-85931"/>
+            </a:stretch>
+          </a:blipFill>
+        </p:spPr>
+      </p:sp>
+      <p:sp>
+        <p:nvSpPr>
+          <p:cNvPr name="Freeform 3" id="3" descr="Orange Blur Circle Illustration"/>
+          <p:cNvSpPr/>
+          <p:nvPr/>
+        </p:nvSpPr>
+        <p:spPr>
+          <a:xfrm flipH="false" flipV="false" rot="0">
+            <a:off x="15450107" y="-97052"/>
+            <a:ext cx="8883833" cy="8883833"/>
+          </a:xfrm>
+          <a:custGeom>
+            <a:avLst/>
+            <a:gdLst/>
+            <a:ahLst/>
+            <a:cxnLst/>
+            <a:rect r="r" b="b" t="t" l="l"/>
+            <a:pathLst>
+              <a:path h="8883833" w="8883833">
+                <a:moveTo>
+                  <a:pt x="0" y="0"/>
+                </a:moveTo>
+                <a:lnTo>
+                  <a:pt x="8883833" y="0"/>
+                </a:lnTo>
+                <a:lnTo>
+                  <a:pt x="8883833" y="8883833"/>
+                </a:lnTo>
+                <a:lnTo>
+                  <a:pt x="0" y="8883833"/>
+                </a:lnTo>
+                <a:lnTo>
+                  <a:pt x="0" y="0"/>
+                </a:lnTo>
+                <a:close/>
+              </a:path>
+            </a:pathLst>
+          </a:custGeom>
+          <a:blipFill>
+            <a:blip r:embed="rId3">
+              <a:alphaModFix amt="26000"/>
+              <a:extLst>
+                <a:ext uri="{96DAC541-7B7A-43D3-8B79-37D633B846F1}">
+                  <asvg:svgBlip xmlns:asvg="http://schemas.microsoft.com/office/drawing/2016/SVG/main" r:embed="rId4"/>
+                </a:ext>
+              </a:extLst>
+            </a:blip>
+            <a:stretch>
+              <a:fillRect l="0" t="0" r="0" b="0"/>
+            </a:stretch>
+          </a:blipFill>
+        </p:spPr>
+      </p:sp>
+      <p:sp>
+        <p:nvSpPr>
+          <p:cNvPr name="Freeform 4" id="4" descr="70's Groovy Wavy Pattern"/>
+          <p:cNvSpPr/>
+          <p:nvPr/>
+        </p:nvSpPr>
+        <p:spPr>
+          <a:xfrm flipH="false" flipV="false" rot="0">
+            <a:off x="0" y="56747"/>
+            <a:ext cx="8708490" cy="1141958"/>
+          </a:xfrm>
+          <a:custGeom>
+            <a:avLst/>
+            <a:gdLst/>
+            <a:ahLst/>
+            <a:cxnLst/>
+            <a:rect r="r" b="b" t="t" l="l"/>
+            <a:pathLst>
+              <a:path h="1141958" w="8708490">
+                <a:moveTo>
+                  <a:pt x="0" y="0"/>
+                </a:moveTo>
+                <a:lnTo>
+                  <a:pt x="8708490" y="0"/>
+                </a:lnTo>
+                <a:lnTo>
+                  <a:pt x="8708490" y="1141958"/>
+                </a:lnTo>
+                <a:lnTo>
+                  <a:pt x="0" y="1141958"/>
+                </a:lnTo>
+                <a:lnTo>
+                  <a:pt x="0" y="0"/>
+                </a:lnTo>
+                <a:close/>
+              </a:path>
+            </a:pathLst>
+          </a:custGeom>
+          <a:blipFill>
+            <a:blip r:embed="rId5">
+              <a:alphaModFix amt="9999"/>
+              <a:extLst>
+                <a:ext uri="{96DAC541-7B7A-43D3-8B79-37D633B846F1}">
+                  <asvg:svgBlip xmlns:asvg="http://schemas.microsoft.com/office/drawing/2016/SVG/main" r:embed="rId6"/>
+                </a:ext>
+              </a:extLst>
+            </a:blip>
+            <a:stretch>
+              <a:fillRect l="-1768" t="0" r="0" b="-680339"/>
+            </a:stretch>
+          </a:blipFill>
+        </p:spPr>
+      </p:sp>
+      <p:sp>
+        <p:nvSpPr>
+          <p:cNvPr name="Freeform 5" id="5" descr="Orange Blur Circle Illustration"/>
+          <p:cNvSpPr/>
+          <p:nvPr/>
+        </p:nvSpPr>
+        <p:spPr>
+          <a:xfrm flipH="false" flipV="false" rot="0">
+            <a:off x="-6049594" y="-97052"/>
+            <a:ext cx="8883833" cy="8883833"/>
+          </a:xfrm>
+          <a:custGeom>
+            <a:avLst/>
+            <a:gdLst/>
+            <a:ahLst/>
+            <a:cxnLst/>
+            <a:rect r="r" b="b" t="t" l="l"/>
+            <a:pathLst>
+              <a:path h="8883833" w="8883833">
+                <a:moveTo>
+                  <a:pt x="0" y="0"/>
+                </a:moveTo>
+                <a:lnTo>
+                  <a:pt x="8883833" y="0"/>
+                </a:lnTo>
+                <a:lnTo>
+                  <a:pt x="8883833" y="8883833"/>
+                </a:lnTo>
+                <a:lnTo>
+                  <a:pt x="0" y="8883833"/>
+                </a:lnTo>
+                <a:lnTo>
+                  <a:pt x="0" y="0"/>
+                </a:lnTo>
+                <a:close/>
+              </a:path>
+            </a:pathLst>
+          </a:custGeom>
+          <a:blipFill>
+            <a:blip r:embed="rId3">
+              <a:alphaModFix amt="26000"/>
+              <a:extLst>
+                <a:ext uri="{96DAC541-7B7A-43D3-8B79-37D633B846F1}">
+                  <asvg:svgBlip xmlns:asvg="http://schemas.microsoft.com/office/drawing/2016/SVG/main" r:embed="rId4"/>
+                </a:ext>
+              </a:extLst>
+            </a:blip>
+            <a:stretch>
+              <a:fillRect l="0" t="0" r="0" b="0"/>
+            </a:stretch>
+          </a:blipFill>
+        </p:spPr>
+      </p:sp>
+      <p:sp>
+        <p:nvSpPr>
+          <p:cNvPr name="Freeform 6" id="6"/>
+          <p:cNvSpPr/>
+          <p:nvPr/>
+        </p:nvSpPr>
+        <p:spPr>
+          <a:xfrm flipH="false" flipV="false" rot="-8291044">
+            <a:off x="14252994" y="-2820751"/>
+            <a:ext cx="7684417" cy="5907396"/>
+          </a:xfrm>
+          <a:custGeom>
+            <a:avLst/>
+            <a:gdLst/>
+            <a:ahLst/>
+            <a:cxnLst/>
+            <a:rect r="r" b="b" t="t" l="l"/>
+            <a:pathLst>
+              <a:path h="5907396" w="7684417">
+                <a:moveTo>
+                  <a:pt x="0" y="0"/>
+                </a:moveTo>
+                <a:lnTo>
+                  <a:pt x="7684418" y="0"/>
+                </a:lnTo>
+                <a:lnTo>
+                  <a:pt x="7684418" y="5907396"/>
+                </a:lnTo>
+                <a:lnTo>
+                  <a:pt x="0" y="5907396"/>
+                </a:lnTo>
+                <a:lnTo>
+                  <a:pt x="0" y="0"/>
+                </a:lnTo>
+                <a:close/>
+              </a:path>
+            </a:pathLst>
+          </a:custGeom>
+          <a:blipFill>
+            <a:blip r:embed="rId7"/>
+            <a:stretch>
+              <a:fillRect l="0" t="0" r="0" b="0"/>
+            </a:stretch>
+          </a:blipFill>
+        </p:spPr>
+      </p:sp>
+      <p:grpSp>
+        <p:nvGrpSpPr>
+          <p:cNvPr name="Group 7" id="7"/>
+          <p:cNvGrpSpPr/>
+          <p:nvPr/>
+        </p:nvGrpSpPr>
+        <p:grpSpPr>
+          <a:xfrm rot="0">
             <a:off x="-2111587" y="-1871305"/>
             <a:ext cx="19803424" cy="11195341"/>
             <a:chOff x="0" y="0"/>
@@ -7670,7 +8770,7 @@
 </p:sld>
 </file>
 
-<file path=ppt/slides/slide6.xml><?xml version="1.0" encoding="utf-8"?>
+<file path=ppt/slides/slide7.xml><?xml version="1.0" encoding="utf-8"?>
 <p:sld xmlns:p="http://schemas.openxmlformats.org/presentationml/2006/main" xmlns:a="http://schemas.openxmlformats.org/drawingml/2006/main" xmlns:r="http://schemas.openxmlformats.org/officeDocument/2006/relationships">
   <p:cSld>
     <p:spTree>
@@ -8928,1547 +10028,6 @@
                     <a:pt x="8697934" y="3195758"/>
                     <a:pt x="8742384" y="3169088"/>
                     <a:pt x="8742384" y="3169088"/>
-                  </a:cubicBezTo>
-                </a:path>
-              </a:pathLst>
-            </a:custGeom>
-            <a:solidFill>
-              <a:srgbClr val="E7191F"/>
-            </a:solidFill>
-            <a:ln cap="sq">
-              <a:noFill/>
-              <a:prstDash val="solid"/>
-              <a:miter/>
-            </a:ln>
-          </p:spPr>
-        </p:sp>
-      </p:grpSp>
-    </p:spTree>
-  </p:cSld>
-  <p:clrMapOvr>
-    <a:masterClrMapping/>
-  </p:clrMapOvr>
-</p:sld>
-</file>
-
-<file path=ppt/slides/slide7.xml><?xml version="1.0" encoding="utf-8"?>
-<p:sld xmlns:p="http://schemas.openxmlformats.org/presentationml/2006/main" xmlns:a="http://schemas.openxmlformats.org/drawingml/2006/main" xmlns:r="http://schemas.openxmlformats.org/officeDocument/2006/relationships">
-  <p:cSld>
-    <p:spTree>
-      <p:nvGrpSpPr>
-        <p:cNvPr id="1" name=""/>
-        <p:cNvGrpSpPr/>
-        <p:nvPr/>
-      </p:nvGrpSpPr>
-      <p:grpSpPr>
-        <a:xfrm>
-          <a:off x="0" y="0"/>
-          <a:ext cx="0" cy="0"/>
-          <a:chOff x="0" y="0"/>
-          <a:chExt cx="0" cy="0"/>
-        </a:xfrm>
-      </p:grpSpPr>
-      <p:sp>
-        <p:nvSpPr>
-          <p:cNvPr name="Freeform 2" id="2"/>
-          <p:cNvSpPr/>
-          <p:nvPr/>
-        </p:nvSpPr>
-        <p:spPr>
-          <a:xfrm flipH="false" flipV="false" rot="0">
-            <a:off x="0" y="0"/>
-            <a:ext cx="18288000" cy="10287000"/>
-          </a:xfrm>
-          <a:custGeom>
-            <a:avLst/>
-            <a:gdLst/>
-            <a:ahLst/>
-            <a:cxnLst/>
-            <a:rect r="r" b="b" t="t" l="l"/>
-            <a:pathLst>
-              <a:path h="10287000" w="18288000">
-                <a:moveTo>
-                  <a:pt x="0" y="0"/>
-                </a:moveTo>
-                <a:lnTo>
-                  <a:pt x="18288000" y="0"/>
-                </a:lnTo>
-                <a:lnTo>
-                  <a:pt x="18288000" y="10287000"/>
-                </a:lnTo>
-                <a:lnTo>
-                  <a:pt x="0" y="10287000"/>
-                </a:lnTo>
-                <a:lnTo>
-                  <a:pt x="0" y="0"/>
-                </a:lnTo>
-                <a:close/>
-              </a:path>
-            </a:pathLst>
-          </a:custGeom>
-          <a:blipFill>
-            <a:blip r:embed="rId2"/>
-            <a:stretch>
-              <a:fillRect l="-8647" t="-18123" r="-6133" b="-85931"/>
-            </a:stretch>
-          </a:blipFill>
-        </p:spPr>
-      </p:sp>
-      <p:sp>
-        <p:nvSpPr>
-          <p:cNvPr name="Freeform 3" id="3" descr="Orange Blur Circle Illustration"/>
-          <p:cNvSpPr/>
-          <p:nvPr/>
-        </p:nvSpPr>
-        <p:spPr>
-          <a:xfrm flipH="false" flipV="false" rot="0">
-            <a:off x="15450107" y="-97052"/>
-            <a:ext cx="8883833" cy="8883833"/>
-          </a:xfrm>
-          <a:custGeom>
-            <a:avLst/>
-            <a:gdLst/>
-            <a:ahLst/>
-            <a:cxnLst/>
-            <a:rect r="r" b="b" t="t" l="l"/>
-            <a:pathLst>
-              <a:path h="8883833" w="8883833">
-                <a:moveTo>
-                  <a:pt x="0" y="0"/>
-                </a:moveTo>
-                <a:lnTo>
-                  <a:pt x="8883833" y="0"/>
-                </a:lnTo>
-                <a:lnTo>
-                  <a:pt x="8883833" y="8883833"/>
-                </a:lnTo>
-                <a:lnTo>
-                  <a:pt x="0" y="8883833"/>
-                </a:lnTo>
-                <a:lnTo>
-                  <a:pt x="0" y="0"/>
-                </a:lnTo>
-                <a:close/>
-              </a:path>
-            </a:pathLst>
-          </a:custGeom>
-          <a:blipFill>
-            <a:blip r:embed="rId3">
-              <a:alphaModFix amt="26000"/>
-              <a:extLst>
-                <a:ext uri="{96DAC541-7B7A-43D3-8B79-37D633B846F1}">
-                  <asvg:svgBlip xmlns:asvg="http://schemas.microsoft.com/office/drawing/2016/SVG/main" r:embed="rId4"/>
-                </a:ext>
-              </a:extLst>
-            </a:blip>
-            <a:stretch>
-              <a:fillRect l="0" t="0" r="0" b="0"/>
-            </a:stretch>
-          </a:blipFill>
-        </p:spPr>
-      </p:sp>
-      <p:sp>
-        <p:nvSpPr>
-          <p:cNvPr name="Freeform 4" id="4" descr="70's Groovy Wavy Pattern"/>
-          <p:cNvSpPr/>
-          <p:nvPr/>
-        </p:nvSpPr>
-        <p:spPr>
-          <a:xfrm flipH="false" flipV="false" rot="0">
-            <a:off x="0" y="56747"/>
-            <a:ext cx="8708490" cy="1141958"/>
-          </a:xfrm>
-          <a:custGeom>
-            <a:avLst/>
-            <a:gdLst/>
-            <a:ahLst/>
-            <a:cxnLst/>
-            <a:rect r="r" b="b" t="t" l="l"/>
-            <a:pathLst>
-              <a:path h="1141958" w="8708490">
-                <a:moveTo>
-                  <a:pt x="0" y="0"/>
-                </a:moveTo>
-                <a:lnTo>
-                  <a:pt x="8708490" y="0"/>
-                </a:lnTo>
-                <a:lnTo>
-                  <a:pt x="8708490" y="1141958"/>
-                </a:lnTo>
-                <a:lnTo>
-                  <a:pt x="0" y="1141958"/>
-                </a:lnTo>
-                <a:lnTo>
-                  <a:pt x="0" y="0"/>
-                </a:lnTo>
-                <a:close/>
-              </a:path>
-            </a:pathLst>
-          </a:custGeom>
-          <a:blipFill>
-            <a:blip r:embed="rId5">
-              <a:alphaModFix amt="9999"/>
-              <a:extLst>
-                <a:ext uri="{96DAC541-7B7A-43D3-8B79-37D633B846F1}">
-                  <asvg:svgBlip xmlns:asvg="http://schemas.microsoft.com/office/drawing/2016/SVG/main" r:embed="rId6"/>
-                </a:ext>
-              </a:extLst>
-            </a:blip>
-            <a:stretch>
-              <a:fillRect l="-1768" t="0" r="0" b="-680339"/>
-            </a:stretch>
-          </a:blipFill>
-        </p:spPr>
-      </p:sp>
-      <p:sp>
-        <p:nvSpPr>
-          <p:cNvPr name="Freeform 5" id="5" descr="Orange Blur Circle Illustration"/>
-          <p:cNvSpPr/>
-          <p:nvPr/>
-        </p:nvSpPr>
-        <p:spPr>
-          <a:xfrm flipH="false" flipV="false" rot="0">
-            <a:off x="-6049594" y="-97052"/>
-            <a:ext cx="8883833" cy="8883833"/>
-          </a:xfrm>
-          <a:custGeom>
-            <a:avLst/>
-            <a:gdLst/>
-            <a:ahLst/>
-            <a:cxnLst/>
-            <a:rect r="r" b="b" t="t" l="l"/>
-            <a:pathLst>
-              <a:path h="8883833" w="8883833">
-                <a:moveTo>
-                  <a:pt x="0" y="0"/>
-                </a:moveTo>
-                <a:lnTo>
-                  <a:pt x="8883833" y="0"/>
-                </a:lnTo>
-                <a:lnTo>
-                  <a:pt x="8883833" y="8883833"/>
-                </a:lnTo>
-                <a:lnTo>
-                  <a:pt x="0" y="8883833"/>
-                </a:lnTo>
-                <a:lnTo>
-                  <a:pt x="0" y="0"/>
-                </a:lnTo>
-                <a:close/>
-              </a:path>
-            </a:pathLst>
-          </a:custGeom>
-          <a:blipFill>
-            <a:blip r:embed="rId3">
-              <a:alphaModFix amt="26000"/>
-              <a:extLst>
-                <a:ext uri="{96DAC541-7B7A-43D3-8B79-37D633B846F1}">
-                  <asvg:svgBlip xmlns:asvg="http://schemas.microsoft.com/office/drawing/2016/SVG/main" r:embed="rId4"/>
-                </a:ext>
-              </a:extLst>
-            </a:blip>
-            <a:stretch>
-              <a:fillRect l="0" t="0" r="0" b="0"/>
-            </a:stretch>
-          </a:blipFill>
-        </p:spPr>
-      </p:sp>
-      <p:sp>
-        <p:nvSpPr>
-          <p:cNvPr name="Freeform 6" id="6"/>
-          <p:cNvSpPr/>
-          <p:nvPr/>
-        </p:nvSpPr>
-        <p:spPr>
-          <a:xfrm flipH="false" flipV="false" rot="-8291044">
-            <a:off x="14252994" y="-2820751"/>
-            <a:ext cx="7684417" cy="5907396"/>
-          </a:xfrm>
-          <a:custGeom>
-            <a:avLst/>
-            <a:gdLst/>
-            <a:ahLst/>
-            <a:cxnLst/>
-            <a:rect r="r" b="b" t="t" l="l"/>
-            <a:pathLst>
-              <a:path h="5907396" w="7684417">
-                <a:moveTo>
-                  <a:pt x="0" y="0"/>
-                </a:moveTo>
-                <a:lnTo>
-                  <a:pt x="7684418" y="0"/>
-                </a:lnTo>
-                <a:lnTo>
-                  <a:pt x="7684418" y="5907396"/>
-                </a:lnTo>
-                <a:lnTo>
-                  <a:pt x="0" y="5907396"/>
-                </a:lnTo>
-                <a:lnTo>
-                  <a:pt x="0" y="0"/>
-                </a:lnTo>
-                <a:close/>
-              </a:path>
-            </a:pathLst>
-          </a:custGeom>
-          <a:blipFill>
-            <a:blip r:embed="rId7"/>
-            <a:stretch>
-              <a:fillRect l="0" t="0" r="0" b="0"/>
-            </a:stretch>
-          </a:blipFill>
-        </p:spPr>
-      </p:sp>
-      <p:grpSp>
-        <p:nvGrpSpPr>
-          <p:cNvPr name="Group 7" id="7"/>
-          <p:cNvGrpSpPr/>
-          <p:nvPr/>
-        </p:nvGrpSpPr>
-        <p:grpSpPr>
-          <a:xfrm rot="0">
-            <a:off x="-3802058" y="-5906380"/>
-            <a:ext cx="22361988" cy="12566000"/>
-            <a:chOff x="0" y="0"/>
-            <a:chExt cx="29815984" cy="16754666"/>
-          </a:xfrm>
-        </p:grpSpPr>
-        <p:pic>
-          <p:nvPicPr>
-            <p:cNvPr name="Picture 8" id="8"/>
-            <p:cNvPicPr>
-              <a:picLocks noChangeAspect="true"/>
-            </p:cNvPicPr>
-            <p:nvPr/>
-          </p:nvPicPr>
-          <p:blipFill>
-            <a:blip r:embed="rId8"/>
-            <a:srcRect l="0" t="3269" r="0" b="3269"/>
-            <a:stretch>
-              <a:fillRect/>
-            </a:stretch>
-          </p:blipFill>
-          <p:spPr>
-            <a:xfrm flipH="false" flipV="false">
-              <a:off x="0" y="0"/>
-              <a:ext cx="29815984" cy="16754666"/>
-            </a:xfrm>
-            <a:prstGeom prst="rect">
-              <a:avLst/>
-            </a:prstGeom>
-          </p:spPr>
-        </p:pic>
-      </p:grpSp>
-      <p:sp>
-        <p:nvSpPr>
-          <p:cNvPr name="Freeform 9" id="9"/>
-          <p:cNvSpPr/>
-          <p:nvPr/>
-        </p:nvSpPr>
-        <p:spPr>
-          <a:xfrm flipH="false" flipV="false" rot="0">
-            <a:off x="0" y="6456064"/>
-            <a:ext cx="19702881" cy="20034489"/>
-          </a:xfrm>
-          <a:custGeom>
-            <a:avLst/>
-            <a:gdLst/>
-            <a:ahLst/>
-            <a:cxnLst/>
-            <a:rect r="r" b="b" t="t" l="l"/>
-            <a:pathLst>
-              <a:path h="20034489" w="19702881">
-                <a:moveTo>
-                  <a:pt x="0" y="0"/>
-                </a:moveTo>
-                <a:lnTo>
-                  <a:pt x="19702881" y="0"/>
-                </a:lnTo>
-                <a:lnTo>
-                  <a:pt x="19702881" y="20034489"/>
-                </a:lnTo>
-                <a:lnTo>
-                  <a:pt x="0" y="20034489"/>
-                </a:lnTo>
-                <a:lnTo>
-                  <a:pt x="0" y="0"/>
-                </a:lnTo>
-                <a:close/>
-              </a:path>
-            </a:pathLst>
-          </a:custGeom>
-          <a:blipFill>
-            <a:blip r:embed="rId9"/>
-            <a:stretch>
-              <a:fillRect l="-47811" t="0" r="-46555" b="0"/>
-            </a:stretch>
-          </a:blipFill>
-        </p:spPr>
-      </p:sp>
-      <p:sp>
-        <p:nvSpPr>
-          <p:cNvPr name="TextBox 10" id="10"/>
-          <p:cNvSpPr txBox="true"/>
-          <p:nvPr/>
-        </p:nvSpPr>
-        <p:spPr>
-          <a:xfrm rot="0">
-            <a:off x="9518477" y="5881523"/>
-            <a:ext cx="8377025" cy="3669283"/>
-          </a:xfrm>
-          <a:prstGeom prst="rect">
-            <a:avLst/>
-          </a:prstGeom>
-        </p:spPr>
-        <p:txBody>
-          <a:bodyPr anchor="t" rtlCol="false" tIns="0" lIns="0" bIns="0" rIns="0">
-            <a:spAutoFit/>
-          </a:bodyPr>
-          <a:lstStyle/>
-          <a:p>
-            <a:pPr algn="l" marL="702495" indent="-351247" lvl="1">
-              <a:lnSpc>
-                <a:spcPts val="4880"/>
-              </a:lnSpc>
-              <a:buFont typeface="Arial"/>
-              <a:buChar char="•"/>
-            </a:pPr>
-            <a:r>
-              <a:rPr lang="en-US" b="true" sz="3253">
-                <a:solidFill>
-                  <a:srgbClr val="FFFFFF"/>
-                </a:solidFill>
-                <a:latin typeface="Garet Bold"/>
-                <a:ea typeface="Garet Bold"/>
-                <a:cs typeface="Garet Bold"/>
-                <a:sym typeface="Garet Bold"/>
-              </a:rPr>
-              <a:t>Após a escolha, envia a matriz o número do jogador para uma função conferir se o jogo foi ganho após a escolha feita</a:t>
-            </a:r>
-          </a:p>
-          <a:p>
-            <a:pPr algn="l" marL="702495" indent="-351247" lvl="1">
-              <a:lnSpc>
-                <a:spcPts val="4880"/>
-              </a:lnSpc>
-              <a:spcBef>
-                <a:spcPct val="0"/>
-              </a:spcBef>
-              <a:buFont typeface="Arial"/>
-              <a:buChar char="•"/>
-            </a:pPr>
-            <a:r>
-              <a:rPr lang="en-US" b="true" sz="3253">
-                <a:solidFill>
-                  <a:srgbClr val="FFFFFF"/>
-                </a:solidFill>
-                <a:latin typeface="Garet Bold"/>
-                <a:ea typeface="Garet Bold"/>
-                <a:cs typeface="Garet Bold"/>
-                <a:sym typeface="Garet Bold"/>
-              </a:rPr>
-              <a:t>Se o jogo não tiver sido ganho, passa a vez para o próximo jogador</a:t>
-            </a:r>
-          </a:p>
-        </p:txBody>
-      </p:sp>
-      <p:sp>
-        <p:nvSpPr>
-          <p:cNvPr name="Freeform 11" id="11"/>
-          <p:cNvSpPr/>
-          <p:nvPr/>
-        </p:nvSpPr>
-        <p:spPr>
-          <a:xfrm flipH="false" flipV="false" rot="0">
-            <a:off x="-1142950" y="-17500280"/>
-            <a:ext cx="19702881" cy="18128006"/>
-          </a:xfrm>
-          <a:custGeom>
-            <a:avLst/>
-            <a:gdLst/>
-            <a:ahLst/>
-            <a:cxnLst/>
-            <a:rect r="r" b="b" t="t" l="l"/>
-            <a:pathLst>
-              <a:path h="18128006" w="19702881">
-                <a:moveTo>
-                  <a:pt x="0" y="0"/>
-                </a:moveTo>
-                <a:lnTo>
-                  <a:pt x="19702880" y="0"/>
-                </a:lnTo>
-                <a:lnTo>
-                  <a:pt x="19702880" y="18128006"/>
-                </a:lnTo>
-                <a:lnTo>
-                  <a:pt x="0" y="18128006"/>
-                </a:lnTo>
-                <a:lnTo>
-                  <a:pt x="0" y="0"/>
-                </a:lnTo>
-                <a:close/>
-              </a:path>
-            </a:pathLst>
-          </a:custGeom>
-          <a:blipFill>
-            <a:blip r:embed="rId9"/>
-            <a:stretch>
-              <a:fillRect l="-38504" t="0" r="-37367" b="0"/>
-            </a:stretch>
-          </a:blipFill>
-        </p:spPr>
-      </p:sp>
-      <p:sp>
-        <p:nvSpPr>
-          <p:cNvPr name="Freeform 12" id="12"/>
-          <p:cNvSpPr/>
-          <p:nvPr/>
-        </p:nvSpPr>
-        <p:spPr>
-          <a:xfrm flipH="false" flipV="false" rot="0">
-            <a:off x="17505033" y="-852337"/>
-            <a:ext cx="19702881" cy="17232253"/>
-          </a:xfrm>
-          <a:custGeom>
-            <a:avLst/>
-            <a:gdLst/>
-            <a:ahLst/>
-            <a:cxnLst/>
-            <a:rect r="r" b="b" t="t" l="l"/>
-            <a:pathLst>
-              <a:path h="17232253" w="19702881">
-                <a:moveTo>
-                  <a:pt x="0" y="0"/>
-                </a:moveTo>
-                <a:lnTo>
-                  <a:pt x="19702881" y="0"/>
-                </a:lnTo>
-                <a:lnTo>
-                  <a:pt x="19702881" y="17232253"/>
-                </a:lnTo>
-                <a:lnTo>
-                  <a:pt x="0" y="17232253"/>
-                </a:lnTo>
-                <a:lnTo>
-                  <a:pt x="0" y="0"/>
-                </a:lnTo>
-                <a:close/>
-              </a:path>
-            </a:pathLst>
-          </a:custGeom>
-          <a:blipFill>
-            <a:blip r:embed="rId9"/>
-            <a:stretch>
-              <a:fillRect l="-34130" t="0" r="-33050" b="0"/>
-            </a:stretch>
-          </a:blipFill>
-        </p:spPr>
-      </p:sp>
-      <p:grpSp>
-        <p:nvGrpSpPr>
-          <p:cNvPr name="Group 13" id="13"/>
-          <p:cNvGrpSpPr/>
-          <p:nvPr/>
-        </p:nvGrpSpPr>
-        <p:grpSpPr>
-          <a:xfrm rot="0">
-            <a:off x="1226820" y="2727008"/>
-            <a:ext cx="12044362" cy="3299460"/>
-            <a:chOff x="0" y="0"/>
-            <a:chExt cx="16059150" cy="4399280"/>
-          </a:xfrm>
-        </p:grpSpPr>
-        <p:sp>
-          <p:nvSpPr>
-            <p:cNvPr name="Freeform 14" id="14"/>
-            <p:cNvSpPr/>
-            <p:nvPr/>
-          </p:nvSpPr>
-          <p:spPr>
-            <a:xfrm flipH="false" flipV="false" rot="0">
-              <a:off x="44768" y="27343"/>
-              <a:ext cx="15969381" cy="4323467"/>
-            </a:xfrm>
-            <a:custGeom>
-              <a:avLst/>
-              <a:gdLst/>
-              <a:ahLst/>
-              <a:cxnLst/>
-              <a:rect r="r" b="b" t="t" l="l"/>
-              <a:pathLst>
-                <a:path h="4323467" w="15969381">
-                  <a:moveTo>
-                    <a:pt x="1075372" y="333337"/>
-                  </a:moveTo>
-                  <a:cubicBezTo>
-                    <a:pt x="1471612" y="328257"/>
-                    <a:pt x="1527492" y="321907"/>
-                    <a:pt x="1588452" y="314287"/>
-                  </a:cubicBezTo>
-                  <a:cubicBezTo>
-                    <a:pt x="1645602" y="306667"/>
-                    <a:pt x="1697672" y="299047"/>
-                    <a:pt x="1752282" y="286347"/>
-                  </a:cubicBezTo>
-                  <a:cubicBezTo>
-                    <a:pt x="1809432" y="272377"/>
-                    <a:pt x="1851342" y="249517"/>
-                    <a:pt x="1922462" y="234277"/>
-                  </a:cubicBezTo>
-                  <a:cubicBezTo>
-                    <a:pt x="2038032" y="208877"/>
-                    <a:pt x="2267902" y="198717"/>
-                    <a:pt x="2382202" y="174587"/>
-                  </a:cubicBezTo>
-                  <a:cubicBezTo>
-                    <a:pt x="2453322" y="159347"/>
-                    <a:pt x="2482532" y="139027"/>
-                    <a:pt x="2552382" y="122517"/>
-                  </a:cubicBezTo>
-                  <a:cubicBezTo>
-                    <a:pt x="2660332" y="98387"/>
-                    <a:pt x="2780982" y="70447"/>
-                    <a:pt x="2970212" y="52667"/>
-                  </a:cubicBezTo>
-                  <a:cubicBezTo>
-                    <a:pt x="3366452" y="18377"/>
-                    <a:pt x="4247832" y="33617"/>
-                    <a:pt x="4815522" y="32347"/>
-                  </a:cubicBezTo>
-                  <a:cubicBezTo>
-                    <a:pt x="5303202" y="31077"/>
-                    <a:pt x="5635942" y="42507"/>
-                    <a:pt x="6174422" y="42507"/>
-                  </a:cubicBezTo>
-                  <a:cubicBezTo>
-                    <a:pt x="6963092" y="42507"/>
-                    <a:pt x="8465502" y="-38773"/>
-                    <a:pt x="9090342" y="23457"/>
-                  </a:cubicBezTo>
-                  <a:cubicBezTo>
-                    <a:pt x="9390062" y="53937"/>
-                    <a:pt x="9600882" y="137757"/>
-                    <a:pt x="9749472" y="160617"/>
-                  </a:cubicBezTo>
-                  <a:cubicBezTo>
-                    <a:pt x="9823132" y="172047"/>
-                    <a:pt x="9849802" y="165697"/>
-                    <a:pt x="9915842" y="177127"/>
-                  </a:cubicBezTo>
-                  <a:cubicBezTo>
-                    <a:pt x="10016172" y="194907"/>
-                    <a:pt x="10176192" y="254597"/>
-                    <a:pt x="10285412" y="272377"/>
-                  </a:cubicBezTo>
-                  <a:cubicBezTo>
-                    <a:pt x="10367962" y="286347"/>
-                    <a:pt x="10397172" y="285077"/>
-                    <a:pt x="10510202" y="290157"/>
-                  </a:cubicBezTo>
-                  <a:cubicBezTo>
-                    <a:pt x="10849292" y="304127"/>
-                    <a:pt x="11819572" y="302857"/>
-                    <a:pt x="12553632" y="302857"/>
-                  </a:cubicBezTo>
-                  <a:cubicBezTo>
-                    <a:pt x="13408343" y="304127"/>
-                    <a:pt x="14957743" y="253327"/>
-                    <a:pt x="15331121" y="286347"/>
-                  </a:cubicBezTo>
-                  <a:cubicBezTo>
-                    <a:pt x="15426371" y="295237"/>
-                    <a:pt x="15444152" y="301587"/>
-                    <a:pt x="15508921" y="319367"/>
-                  </a:cubicBezTo>
-                  <a:cubicBezTo>
-                    <a:pt x="15588932" y="342227"/>
-                    <a:pt x="15709582" y="384137"/>
-                    <a:pt x="15773082" y="420967"/>
-                  </a:cubicBezTo>
-                  <a:cubicBezTo>
-                    <a:pt x="15816262" y="446367"/>
-                    <a:pt x="15841662" y="464147"/>
-                    <a:pt x="15869602" y="500977"/>
-                  </a:cubicBezTo>
-                  <a:cubicBezTo>
-                    <a:pt x="15903893" y="545427"/>
-                    <a:pt x="15933102" y="607657"/>
-                    <a:pt x="15950882" y="681317"/>
-                  </a:cubicBezTo>
-                  <a:cubicBezTo>
-                    <a:pt x="15975012" y="789267"/>
-                    <a:pt x="15971202" y="993737"/>
-                    <a:pt x="15963582" y="1094067"/>
-                  </a:cubicBezTo>
-                  <a:cubicBezTo>
-                    <a:pt x="15958502" y="1151217"/>
-                    <a:pt x="15949612" y="1188047"/>
-                    <a:pt x="15936912" y="1228687"/>
-                  </a:cubicBezTo>
-                  <a:cubicBezTo>
-                    <a:pt x="15925482" y="1265517"/>
-                    <a:pt x="15908971" y="1299807"/>
-                    <a:pt x="15896271" y="1329017"/>
-                  </a:cubicBezTo>
-                  <a:cubicBezTo>
-                    <a:pt x="15883571" y="1355687"/>
-                    <a:pt x="15875952" y="1376007"/>
-                    <a:pt x="15860712" y="1400137"/>
-                  </a:cubicBezTo>
-                  <a:cubicBezTo>
-                    <a:pt x="15840393" y="1430617"/>
-                    <a:pt x="15808643" y="1466177"/>
-                    <a:pt x="15781971" y="1495387"/>
-                  </a:cubicBezTo>
-                  <a:cubicBezTo>
-                    <a:pt x="15757843" y="1523327"/>
-                    <a:pt x="15733712" y="1549997"/>
-                    <a:pt x="15705771" y="1574127"/>
-                  </a:cubicBezTo>
-                  <a:cubicBezTo>
-                    <a:pt x="15674021" y="1600797"/>
-                    <a:pt x="15643543" y="1621117"/>
-                    <a:pt x="15600362" y="1647787"/>
-                  </a:cubicBezTo>
-                  <a:cubicBezTo>
-                    <a:pt x="15540671" y="1684617"/>
-                    <a:pt x="15456852" y="1741767"/>
-                    <a:pt x="15378112" y="1772247"/>
-                  </a:cubicBezTo>
-                  <a:cubicBezTo>
-                    <a:pt x="15295562" y="1805267"/>
-                    <a:pt x="15201582" y="1819237"/>
-                    <a:pt x="15116493" y="1837017"/>
-                  </a:cubicBezTo>
-                  <a:cubicBezTo>
-                    <a:pt x="15033943" y="1853527"/>
-                    <a:pt x="14988221" y="1864957"/>
-                    <a:pt x="14875193" y="1873847"/>
-                  </a:cubicBezTo>
-                  <a:cubicBezTo>
-                    <a:pt x="14619921" y="1894167"/>
-                    <a:pt x="13841412" y="1858607"/>
-                    <a:pt x="13614082" y="1877657"/>
-                  </a:cubicBezTo>
-                  <a:cubicBezTo>
-                    <a:pt x="13528993" y="1885277"/>
-                    <a:pt x="13515021" y="1900517"/>
-                    <a:pt x="13440093" y="1906867"/>
-                  </a:cubicBezTo>
-                  <a:cubicBezTo>
-                    <a:pt x="13305471" y="1918297"/>
-                    <a:pt x="13003212" y="1891627"/>
-                    <a:pt x="12874942" y="1911947"/>
-                  </a:cubicBezTo>
-                  <a:cubicBezTo>
-                    <a:pt x="12805092" y="1922107"/>
-                    <a:pt x="12772072" y="1946237"/>
-                    <a:pt x="12717462" y="1957667"/>
-                  </a:cubicBezTo>
-                  <a:cubicBezTo>
-                    <a:pt x="12661582" y="1970367"/>
-                    <a:pt x="12613322" y="1964017"/>
-                    <a:pt x="12544742" y="1981797"/>
-                  </a:cubicBezTo>
-                  <a:cubicBezTo>
-                    <a:pt x="12435522" y="2008467"/>
-                    <a:pt x="12242482" y="2102447"/>
-                    <a:pt x="12130722" y="2136737"/>
-                  </a:cubicBezTo>
-                  <a:cubicBezTo>
-                    <a:pt x="12059602" y="2158327"/>
-                    <a:pt x="11997372" y="2159597"/>
-                    <a:pt x="11949112" y="2181187"/>
-                  </a:cubicBezTo>
-                  <a:cubicBezTo>
-                    <a:pt x="11913552" y="2198967"/>
-                    <a:pt x="11895772" y="2229447"/>
-                    <a:pt x="11864022" y="2244687"/>
-                  </a:cubicBezTo>
-                  <a:cubicBezTo>
-                    <a:pt x="11829732" y="2261197"/>
-                    <a:pt x="11792902" y="2259927"/>
-                    <a:pt x="11750992" y="2277707"/>
-                  </a:cubicBezTo>
-                  <a:cubicBezTo>
-                    <a:pt x="11692572" y="2300567"/>
-                    <a:pt x="11603672" y="2346287"/>
-                    <a:pt x="11550332" y="2381847"/>
-                  </a:cubicBezTo>
-                  <a:cubicBezTo>
-                    <a:pt x="11510962" y="2408517"/>
-                    <a:pt x="11486832" y="2444077"/>
-                    <a:pt x="11453812" y="2463127"/>
-                  </a:cubicBezTo>
-                  <a:cubicBezTo>
-                    <a:pt x="11424602" y="2479637"/>
-                    <a:pt x="11392852" y="2478367"/>
-                    <a:pt x="11366182" y="2493607"/>
-                  </a:cubicBezTo>
-                  <a:cubicBezTo>
-                    <a:pt x="11336972" y="2510117"/>
-                    <a:pt x="11317922" y="2540597"/>
-                    <a:pt x="11288712" y="2559647"/>
-                  </a:cubicBezTo>
-                  <a:cubicBezTo>
-                    <a:pt x="11253152" y="2579967"/>
-                    <a:pt x="11211242" y="2585047"/>
-                    <a:pt x="11168062" y="2609177"/>
-                  </a:cubicBezTo>
-                  <a:cubicBezTo>
-                    <a:pt x="11109642" y="2642197"/>
-                    <a:pt x="11041062" y="2713317"/>
-                    <a:pt x="10975022" y="2752687"/>
-                  </a:cubicBezTo>
-                  <a:cubicBezTo>
-                    <a:pt x="10914062" y="2788247"/>
-                    <a:pt x="10837862" y="2808567"/>
-                    <a:pt x="10787062" y="2837777"/>
-                  </a:cubicBezTo>
-                  <a:cubicBezTo>
-                    <a:pt x="10748962" y="2859367"/>
-                    <a:pt x="10718482" y="2879687"/>
-                    <a:pt x="10693082" y="2902547"/>
-                  </a:cubicBezTo>
-                  <a:cubicBezTo>
-                    <a:pt x="10672762" y="2921597"/>
-                    <a:pt x="10667682" y="2940647"/>
-                    <a:pt x="10643552" y="2962237"/>
-                  </a:cubicBezTo>
-                  <a:cubicBezTo>
-                    <a:pt x="10602912" y="2995257"/>
-                    <a:pt x="10525442" y="3034627"/>
-                    <a:pt x="10460672" y="3068917"/>
-                  </a:cubicBezTo>
-                  <a:cubicBezTo>
-                    <a:pt x="10392092" y="3107017"/>
-                    <a:pt x="10318432" y="3146387"/>
-                    <a:pt x="10240962" y="3178137"/>
-                  </a:cubicBezTo>
-                  <a:cubicBezTo>
-                    <a:pt x="10160952" y="3211157"/>
-                    <a:pt x="10063162" y="3228937"/>
-                    <a:pt x="9985692" y="3261957"/>
-                  </a:cubicBezTo>
-                  <a:cubicBezTo>
-                    <a:pt x="9915842" y="3291167"/>
-                    <a:pt x="9848532" y="3341967"/>
-                    <a:pt x="9796462" y="3361017"/>
-                  </a:cubicBezTo>
-                  <a:cubicBezTo>
-                    <a:pt x="9762172" y="3374987"/>
-                    <a:pt x="9738042" y="3378797"/>
-                    <a:pt x="9706292" y="3382607"/>
-                  </a:cubicBezTo>
-                  <a:cubicBezTo>
-                    <a:pt x="9673272" y="3387687"/>
-                    <a:pt x="9650412" y="3382607"/>
-                    <a:pt x="9603422" y="3388957"/>
-                  </a:cubicBezTo>
-                  <a:cubicBezTo>
-                    <a:pt x="9505632" y="3402927"/>
-                    <a:pt x="9261792" y="3479127"/>
-                    <a:pt x="9152572" y="3494367"/>
-                  </a:cubicBezTo>
-                  <a:cubicBezTo>
-                    <a:pt x="9091612" y="3501987"/>
-                    <a:pt x="9056052" y="3489287"/>
-                    <a:pt x="9009062" y="3500717"/>
-                  </a:cubicBezTo>
-                  <a:cubicBezTo>
-                    <a:pt x="8959532" y="3510877"/>
-                    <a:pt x="8939212" y="3537547"/>
-                    <a:pt x="8865552" y="3560407"/>
-                  </a:cubicBezTo>
-                  <a:cubicBezTo>
-                    <a:pt x="8647112" y="3626447"/>
-                    <a:pt x="7821612" y="3790277"/>
-                    <a:pt x="7530782" y="3824567"/>
-                  </a:cubicBezTo>
-                  <a:cubicBezTo>
-                    <a:pt x="7389812" y="3841077"/>
-                    <a:pt x="7284402" y="3822027"/>
-                    <a:pt x="7215822" y="3835997"/>
-                  </a:cubicBezTo>
-                  <a:cubicBezTo>
-                    <a:pt x="7181532" y="3843617"/>
-                    <a:pt x="7175182" y="3858857"/>
-                    <a:pt x="7140892" y="3865207"/>
-                  </a:cubicBezTo>
-                  <a:cubicBezTo>
-                    <a:pt x="7074852" y="3879177"/>
-                    <a:pt x="6945312" y="3860127"/>
-                    <a:pt x="6846252" y="3872827"/>
-                  </a:cubicBezTo>
-                  <a:cubicBezTo>
-                    <a:pt x="6744652" y="3886797"/>
-                    <a:pt x="6644322" y="3932517"/>
-                    <a:pt x="6541452" y="3945217"/>
-                  </a:cubicBezTo>
-                  <a:cubicBezTo>
-                    <a:pt x="6441122" y="3957917"/>
-                    <a:pt x="6328092" y="3941407"/>
-                    <a:pt x="6235382" y="3950297"/>
-                  </a:cubicBezTo>
-                  <a:cubicBezTo>
-                    <a:pt x="6159182" y="3956647"/>
-                    <a:pt x="6086792" y="3978237"/>
-                    <a:pt x="6024562" y="3983317"/>
-                  </a:cubicBezTo>
-                  <a:cubicBezTo>
-                    <a:pt x="5976302" y="3987127"/>
-                    <a:pt x="5934392" y="3974427"/>
-                    <a:pt x="5895022" y="3984587"/>
-                  </a:cubicBezTo>
-                  <a:cubicBezTo>
-                    <a:pt x="5856922" y="3994747"/>
-                    <a:pt x="5835332" y="4025227"/>
-                    <a:pt x="5792152" y="4041737"/>
-                  </a:cubicBezTo>
-                  <a:cubicBezTo>
-                    <a:pt x="5728652" y="4064597"/>
-                    <a:pt x="5675312" y="4079837"/>
-                    <a:pt x="5547042" y="4092537"/>
-                  </a:cubicBezTo>
-                  <a:cubicBezTo>
-                    <a:pt x="5086032" y="4140797"/>
-                    <a:pt x="2887662" y="4048087"/>
-                    <a:pt x="2358072" y="4098887"/>
-                  </a:cubicBezTo>
-                  <a:cubicBezTo>
-                    <a:pt x="2180272" y="4116667"/>
-                    <a:pt x="2126932" y="4136987"/>
-                    <a:pt x="2003742" y="4167467"/>
-                  </a:cubicBezTo>
-                  <a:cubicBezTo>
-                    <a:pt x="1866582" y="4200487"/>
-                    <a:pt x="1688782" y="4271607"/>
-                    <a:pt x="1570672" y="4294467"/>
-                  </a:cubicBezTo>
-                  <a:cubicBezTo>
-                    <a:pt x="1491932" y="4310977"/>
-                    <a:pt x="1443672" y="4312247"/>
-                    <a:pt x="1370012" y="4316057"/>
-                  </a:cubicBezTo>
-                  <a:cubicBezTo>
-                    <a:pt x="1279842" y="4321137"/>
-                    <a:pt x="1143952" y="4321137"/>
-                    <a:pt x="1065212" y="4319867"/>
-                  </a:cubicBezTo>
-                  <a:cubicBezTo>
-                    <a:pt x="1016952" y="4319867"/>
-                    <a:pt x="982662" y="4328757"/>
-                    <a:pt x="945832" y="4318597"/>
-                  </a:cubicBezTo>
-                  <a:cubicBezTo>
-                    <a:pt x="910272" y="4308437"/>
-                    <a:pt x="877252" y="4283037"/>
-                    <a:pt x="848042" y="4261447"/>
-                  </a:cubicBezTo>
-                  <a:cubicBezTo>
-                    <a:pt x="820102" y="4241127"/>
-                    <a:pt x="799782" y="4225887"/>
-                    <a:pt x="773112" y="4192867"/>
-                  </a:cubicBezTo>
-                  <a:cubicBezTo>
-                    <a:pt x="729932" y="4135717"/>
-                    <a:pt x="680402" y="4034117"/>
-                    <a:pt x="632142" y="3935057"/>
-                  </a:cubicBezTo>
-                  <a:cubicBezTo>
-                    <a:pt x="568642" y="3804247"/>
-                    <a:pt x="497522" y="3634067"/>
-                    <a:pt x="432752" y="3471507"/>
-                  </a:cubicBezTo>
-                  <a:cubicBezTo>
-                    <a:pt x="362902" y="3293707"/>
-                    <a:pt x="295592" y="3073997"/>
-                    <a:pt x="232092" y="2905087"/>
-                  </a:cubicBezTo>
-                  <a:cubicBezTo>
-                    <a:pt x="178752" y="2766657"/>
-                    <a:pt x="115252" y="2656167"/>
-                    <a:pt x="78422" y="2529167"/>
-                  </a:cubicBezTo>
-                  <a:cubicBezTo>
-                    <a:pt x="44132" y="2407247"/>
-                    <a:pt x="25082" y="2294217"/>
-                    <a:pt x="12382" y="2158327"/>
-                  </a:cubicBezTo>
-                  <a:cubicBezTo>
-                    <a:pt x="-2858" y="1994497"/>
-                    <a:pt x="-2858" y="1734147"/>
-                    <a:pt x="6032" y="1613497"/>
-                  </a:cubicBezTo>
-                  <a:cubicBezTo>
-                    <a:pt x="11112" y="1552537"/>
-                    <a:pt x="25082" y="1532217"/>
-                    <a:pt x="30162" y="1476337"/>
-                  </a:cubicBezTo>
-                  <a:cubicBezTo>
-                    <a:pt x="40322" y="1389977"/>
-                    <a:pt x="36512" y="1228687"/>
-                    <a:pt x="45402" y="1144867"/>
-                  </a:cubicBezTo>
-                  <a:cubicBezTo>
-                    <a:pt x="51752" y="1092797"/>
-                    <a:pt x="58102" y="1057237"/>
-                    <a:pt x="69532" y="1020407"/>
-                  </a:cubicBezTo>
-                  <a:cubicBezTo>
-                    <a:pt x="78422" y="989927"/>
-                    <a:pt x="87312" y="970877"/>
-                    <a:pt x="103822" y="937857"/>
-                  </a:cubicBezTo>
-                  <a:cubicBezTo>
-                    <a:pt x="129222" y="881977"/>
-                    <a:pt x="177482" y="777837"/>
-                    <a:pt x="215582" y="723227"/>
-                  </a:cubicBezTo>
-                  <a:cubicBezTo>
-                    <a:pt x="242252" y="683857"/>
-                    <a:pt x="266382" y="652107"/>
-                    <a:pt x="296862" y="631787"/>
-                  </a:cubicBezTo>
-                  <a:cubicBezTo>
-                    <a:pt x="323532" y="612737"/>
-                    <a:pt x="352742" y="612737"/>
-                    <a:pt x="383222" y="597497"/>
-                  </a:cubicBezTo>
-                  <a:cubicBezTo>
-                    <a:pt x="417512" y="579717"/>
-                    <a:pt x="442912" y="554317"/>
-                    <a:pt x="491172" y="528917"/>
-                  </a:cubicBezTo>
-                  <a:cubicBezTo>
-                    <a:pt x="578802" y="484467"/>
-                    <a:pt x="729932" y="401917"/>
-                    <a:pt x="870902" y="371437"/>
-                  </a:cubicBezTo>
-                  <a:cubicBezTo>
-                    <a:pt x="1030922" y="337147"/>
-                    <a:pt x="1315402" y="334607"/>
-                    <a:pt x="1408112" y="356197"/>
-                  </a:cubicBezTo>
-                  <a:cubicBezTo>
-                    <a:pt x="1441132" y="363817"/>
-                    <a:pt x="1461452" y="372707"/>
-                    <a:pt x="1472882" y="390487"/>
-                  </a:cubicBezTo>
-                  <a:cubicBezTo>
-                    <a:pt x="1485582" y="408267"/>
-                    <a:pt x="1489392" y="443827"/>
-                    <a:pt x="1481772" y="465417"/>
-                  </a:cubicBezTo>
-                  <a:cubicBezTo>
-                    <a:pt x="1472882" y="485737"/>
-                    <a:pt x="1446212" y="508597"/>
-                    <a:pt x="1424622" y="513677"/>
-                  </a:cubicBezTo>
-                  <a:cubicBezTo>
-                    <a:pt x="1403032" y="517487"/>
-                    <a:pt x="1368742" y="508597"/>
-                    <a:pt x="1352232" y="493357"/>
-                  </a:cubicBezTo>
-                  <a:cubicBezTo>
-                    <a:pt x="1336992" y="478117"/>
-                    <a:pt x="1325562" y="443827"/>
-                    <a:pt x="1329372" y="422237"/>
-                  </a:cubicBezTo>
-                  <a:cubicBezTo>
-                    <a:pt x="1331912" y="400647"/>
-                    <a:pt x="1356042" y="372707"/>
-                    <a:pt x="1373822" y="362547"/>
-                  </a:cubicBezTo>
-                  <a:cubicBezTo>
-                    <a:pt x="1389062" y="354927"/>
-                    <a:pt x="1408112" y="352387"/>
-                    <a:pt x="1424622" y="357467"/>
-                  </a:cubicBezTo>
-                  <a:cubicBezTo>
-                    <a:pt x="1444942" y="363817"/>
-                    <a:pt x="1472882" y="387947"/>
-                    <a:pt x="1481772" y="405727"/>
-                  </a:cubicBezTo>
-                  <a:cubicBezTo>
-                    <a:pt x="1489392" y="420967"/>
-                    <a:pt x="1490662" y="440017"/>
-                    <a:pt x="1484312" y="456527"/>
-                  </a:cubicBezTo>
-                  <a:cubicBezTo>
-                    <a:pt x="1476692" y="475577"/>
-                    <a:pt x="1462722" y="497167"/>
-                    <a:pt x="1433512" y="511137"/>
-                  </a:cubicBezTo>
-                  <a:cubicBezTo>
-                    <a:pt x="1352232" y="546697"/>
-                    <a:pt x="1061402" y="492087"/>
-                    <a:pt x="912812" y="518757"/>
-                  </a:cubicBezTo>
-                  <a:cubicBezTo>
-                    <a:pt x="795972" y="541617"/>
-                    <a:pt x="701992" y="587337"/>
-                    <a:pt x="608012" y="631787"/>
-                  </a:cubicBezTo>
-                  <a:cubicBezTo>
-                    <a:pt x="520382" y="672427"/>
-                    <a:pt x="417512" y="729577"/>
-                    <a:pt x="366712" y="772757"/>
-                  </a:cubicBezTo>
-                  <a:cubicBezTo>
-                    <a:pt x="337502" y="796887"/>
-                    <a:pt x="328612" y="810857"/>
-                    <a:pt x="308292" y="842607"/>
-                  </a:cubicBezTo>
-                  <a:cubicBezTo>
-                    <a:pt x="275272" y="892137"/>
-                    <a:pt x="223202" y="991197"/>
-                    <a:pt x="202882" y="1048347"/>
-                  </a:cubicBezTo>
-                  <a:cubicBezTo>
-                    <a:pt x="188912" y="1086447"/>
-                    <a:pt x="186372" y="1106767"/>
-                    <a:pt x="182562" y="1147407"/>
-                  </a:cubicBezTo>
-                  <a:cubicBezTo>
-                    <a:pt x="176212" y="1207097"/>
-                    <a:pt x="182562" y="1299807"/>
-                    <a:pt x="177482" y="1376007"/>
-                  </a:cubicBezTo>
-                  <a:cubicBezTo>
-                    <a:pt x="172402" y="1454747"/>
-                    <a:pt x="155892" y="1518247"/>
-                    <a:pt x="150812" y="1613497"/>
-                  </a:cubicBezTo>
-                  <a:cubicBezTo>
-                    <a:pt x="141922" y="1757007"/>
-                    <a:pt x="147002" y="2027517"/>
-                    <a:pt x="152082" y="2148167"/>
-                  </a:cubicBezTo>
-                  <a:cubicBezTo>
-                    <a:pt x="154622" y="2210397"/>
-                    <a:pt x="157162" y="2239607"/>
-                    <a:pt x="163512" y="2289137"/>
-                  </a:cubicBezTo>
-                  <a:cubicBezTo>
-                    <a:pt x="173672" y="2350097"/>
-                    <a:pt x="180022" y="2397087"/>
-                    <a:pt x="206692" y="2484717"/>
-                  </a:cubicBezTo>
-                  <a:cubicBezTo>
-                    <a:pt x="263842" y="2680297"/>
-                    <a:pt x="441642" y="3143847"/>
-                    <a:pt x="553402" y="3409277"/>
-                  </a:cubicBezTo>
-                  <a:cubicBezTo>
-                    <a:pt x="641032" y="3615017"/>
-                    <a:pt x="747712" y="3830917"/>
-                    <a:pt x="808672" y="3947757"/>
-                  </a:cubicBezTo>
-                  <a:cubicBezTo>
-                    <a:pt x="840422" y="4007447"/>
-                    <a:pt x="853122" y="4043007"/>
-                    <a:pt x="884872" y="4078567"/>
-                  </a:cubicBezTo>
-                  <a:cubicBezTo>
-                    <a:pt x="915352" y="4110317"/>
-                    <a:pt x="940752" y="4138257"/>
-                    <a:pt x="991552" y="4154767"/>
-                  </a:cubicBezTo>
-                  <a:cubicBezTo>
-                    <a:pt x="1081722" y="4183977"/>
-                    <a:pt x="1307782" y="4161117"/>
-                    <a:pt x="1404302" y="4156037"/>
-                  </a:cubicBezTo>
-                  <a:cubicBezTo>
-                    <a:pt x="1457642" y="4152227"/>
-                    <a:pt x="1477962" y="4152227"/>
-                    <a:pt x="1526222" y="4142067"/>
-                  </a:cubicBezTo>
-                  <a:cubicBezTo>
-                    <a:pt x="1601152" y="4124287"/>
-                    <a:pt x="1734502" y="4058247"/>
-                    <a:pt x="1806892" y="4044277"/>
-                  </a:cubicBezTo>
-                  <a:cubicBezTo>
-                    <a:pt x="1850072" y="4035387"/>
-                    <a:pt x="1869122" y="4046817"/>
-                    <a:pt x="1912302" y="4039197"/>
-                  </a:cubicBezTo>
-                  <a:cubicBezTo>
-                    <a:pt x="1982152" y="4027767"/>
-                    <a:pt x="2102802" y="3976967"/>
-                    <a:pt x="2184082" y="3959187"/>
-                  </a:cubicBezTo>
-                  <a:cubicBezTo>
-                    <a:pt x="2247582" y="3945217"/>
-                    <a:pt x="2262822" y="3940137"/>
-                    <a:pt x="2358072" y="3933787"/>
-                  </a:cubicBezTo>
-                  <a:cubicBezTo>
-                    <a:pt x="2759392" y="3905847"/>
-                    <a:pt x="5232082" y="3954107"/>
-                    <a:pt x="5530532" y="3933787"/>
-                  </a:cubicBezTo>
-                  <a:cubicBezTo>
-                    <a:pt x="5581332" y="3931247"/>
-                    <a:pt x="5580062" y="3929977"/>
-                    <a:pt x="5616892" y="3922357"/>
-                  </a:cubicBezTo>
-                  <a:cubicBezTo>
-                    <a:pt x="5693092" y="3907117"/>
-                    <a:pt x="5867082" y="3839807"/>
-                    <a:pt x="5954712" y="3823297"/>
-                  </a:cubicBezTo>
-                  <a:cubicBezTo>
-                    <a:pt x="6008052" y="3814407"/>
-                    <a:pt x="6046152" y="3820757"/>
-                    <a:pt x="6085522" y="3813137"/>
-                  </a:cubicBezTo>
-                  <a:cubicBezTo>
-                    <a:pt x="6118542" y="3806787"/>
-                    <a:pt x="6136322" y="3794087"/>
-                    <a:pt x="6175692" y="3787737"/>
-                  </a:cubicBezTo>
-                  <a:cubicBezTo>
-                    <a:pt x="6245542" y="3778847"/>
-                    <a:pt x="6392862" y="3791547"/>
-                    <a:pt x="6470332" y="3787737"/>
-                  </a:cubicBezTo>
-                  <a:cubicBezTo>
-                    <a:pt x="6519862" y="3785197"/>
-                    <a:pt x="6547802" y="3785197"/>
-                    <a:pt x="6593522" y="3776307"/>
-                  </a:cubicBezTo>
-                  <a:cubicBezTo>
-                    <a:pt x="6653212" y="3764877"/>
-                    <a:pt x="6724332" y="3726777"/>
-                    <a:pt x="6795452" y="3716617"/>
-                  </a:cubicBezTo>
-                  <a:cubicBezTo>
-                    <a:pt x="6871652" y="3705187"/>
-                    <a:pt x="6958012" y="3720427"/>
-                    <a:pt x="7039292" y="3714077"/>
-                  </a:cubicBezTo>
-                  <a:cubicBezTo>
-                    <a:pt x="7118032" y="3707727"/>
-                    <a:pt x="7191692" y="3687407"/>
-                    <a:pt x="7275512" y="3679787"/>
-                  </a:cubicBezTo>
-                  <a:cubicBezTo>
-                    <a:pt x="7368222" y="3670897"/>
-                    <a:pt x="7464742" y="3681057"/>
-                    <a:pt x="7575232" y="3667087"/>
-                  </a:cubicBezTo>
-                  <a:cubicBezTo>
-                    <a:pt x="7712392" y="3649307"/>
-                    <a:pt x="7923212" y="3584537"/>
-                    <a:pt x="8036242" y="3569297"/>
-                  </a:cubicBezTo>
-                  <a:cubicBezTo>
-                    <a:pt x="8099742" y="3559137"/>
-                    <a:pt x="8131492" y="3566757"/>
-                    <a:pt x="8188642" y="3556597"/>
-                  </a:cubicBezTo>
-                  <a:cubicBezTo>
-                    <a:pt x="8264842" y="3542627"/>
-                    <a:pt x="8351202" y="3505797"/>
-                    <a:pt x="8448992" y="3481667"/>
-                  </a:cubicBezTo>
-                  <a:cubicBezTo>
-                    <a:pt x="8575992" y="3452457"/>
-                    <a:pt x="8791892" y="3432137"/>
-                    <a:pt x="8888412" y="3400387"/>
-                  </a:cubicBezTo>
-                  <a:cubicBezTo>
-                    <a:pt x="8937942" y="3383877"/>
-                    <a:pt x="8954452" y="3359747"/>
-                    <a:pt x="8997632" y="3348317"/>
-                  </a:cubicBezTo>
-                  <a:cubicBezTo>
-                    <a:pt x="9050972" y="3334347"/>
-                    <a:pt x="9114472" y="3345777"/>
-                    <a:pt x="9190672" y="3334347"/>
-                  </a:cubicBezTo>
-                  <a:cubicBezTo>
-                    <a:pt x="9301162" y="3316567"/>
-                    <a:pt x="9509442" y="3245447"/>
-                    <a:pt x="9593262" y="3232747"/>
-                  </a:cubicBezTo>
-                  <a:cubicBezTo>
-                    <a:pt x="9630092" y="3226397"/>
-                    <a:pt x="9646602" y="3232747"/>
-                    <a:pt x="9674542" y="3226397"/>
-                  </a:cubicBezTo>
-                  <a:cubicBezTo>
-                    <a:pt x="9706292" y="3220047"/>
-                    <a:pt x="9736772" y="3207347"/>
-                    <a:pt x="9773602" y="3190837"/>
-                  </a:cubicBezTo>
-                  <a:cubicBezTo>
-                    <a:pt x="9821862" y="3170517"/>
-                    <a:pt x="9870122" y="3137497"/>
-                    <a:pt x="9937432" y="3108287"/>
-                  </a:cubicBezTo>
-                  <a:cubicBezTo>
-                    <a:pt x="10039032" y="3065107"/>
-                    <a:pt x="10242232" y="3007957"/>
-                    <a:pt x="10328592" y="2963507"/>
-                  </a:cubicBezTo>
-                  <a:cubicBezTo>
-                    <a:pt x="10375582" y="2940647"/>
-                    <a:pt x="10399712" y="2910167"/>
-                    <a:pt x="10432732" y="2896197"/>
-                  </a:cubicBezTo>
-                  <a:cubicBezTo>
-                    <a:pt x="10458132" y="2884767"/>
-                    <a:pt x="10484802" y="2892387"/>
-                    <a:pt x="10507662" y="2878417"/>
-                  </a:cubicBezTo>
-                  <a:cubicBezTo>
-                    <a:pt x="10535602" y="2860637"/>
-                    <a:pt x="10549572" y="2812377"/>
-                    <a:pt x="10578782" y="2785707"/>
-                  </a:cubicBezTo>
-                  <a:cubicBezTo>
-                    <a:pt x="10610532" y="2756497"/>
-                    <a:pt x="10648632" y="2738717"/>
-                    <a:pt x="10693082" y="2713317"/>
-                  </a:cubicBezTo>
-                  <a:cubicBezTo>
-                    <a:pt x="10752772" y="2677757"/>
-                    <a:pt x="10850562" y="2620607"/>
-                    <a:pt x="10910252" y="2595207"/>
-                  </a:cubicBezTo>
-                  <a:cubicBezTo>
-                    <a:pt x="10949622" y="2577427"/>
-                    <a:pt x="10986452" y="2579967"/>
-                    <a:pt x="11013122" y="2560917"/>
-                  </a:cubicBezTo>
-                  <a:cubicBezTo>
-                    <a:pt x="11035982" y="2544407"/>
-                    <a:pt x="11039792" y="2511387"/>
-                    <a:pt x="11063922" y="2492337"/>
-                  </a:cubicBezTo>
-                  <a:cubicBezTo>
-                    <a:pt x="11094402" y="2469477"/>
-                    <a:pt x="11152822" y="2461857"/>
-                    <a:pt x="11185842" y="2440267"/>
-                  </a:cubicBezTo>
-                  <a:cubicBezTo>
-                    <a:pt x="11215052" y="2422487"/>
-                    <a:pt x="11231562" y="2394547"/>
-                    <a:pt x="11258232" y="2378037"/>
-                  </a:cubicBezTo>
-                  <a:cubicBezTo>
-                    <a:pt x="11287442" y="2361527"/>
-                    <a:pt x="11325542" y="2360257"/>
-                    <a:pt x="11356022" y="2342477"/>
-                  </a:cubicBezTo>
-                  <a:cubicBezTo>
-                    <a:pt x="11387772" y="2324697"/>
-                    <a:pt x="11411902" y="2286597"/>
-                    <a:pt x="11444922" y="2267547"/>
-                  </a:cubicBezTo>
-                  <a:cubicBezTo>
-                    <a:pt x="11475402" y="2249767"/>
-                    <a:pt x="11512232" y="2249767"/>
-                    <a:pt x="11543982" y="2231987"/>
-                  </a:cubicBezTo>
-                  <a:cubicBezTo>
-                    <a:pt x="11580812" y="2212937"/>
-                    <a:pt x="11607482" y="2178647"/>
-                    <a:pt x="11650662" y="2157057"/>
-                  </a:cubicBezTo>
-                  <a:cubicBezTo>
-                    <a:pt x="11702732" y="2129117"/>
-                    <a:pt x="11795442" y="2112607"/>
-                    <a:pt x="11841162" y="2088477"/>
-                  </a:cubicBezTo>
-                  <a:cubicBezTo>
-                    <a:pt x="11869102" y="2074507"/>
-                    <a:pt x="11877992" y="2056727"/>
-                    <a:pt x="11905932" y="2045297"/>
-                  </a:cubicBezTo>
-                  <a:cubicBezTo>
-                    <a:pt x="11947842" y="2026247"/>
-                    <a:pt x="12008802" y="2023707"/>
-                    <a:pt x="12074842" y="2003387"/>
-                  </a:cubicBezTo>
-                  <a:cubicBezTo>
-                    <a:pt x="12173902" y="1971637"/>
-                    <a:pt x="12360592" y="1889087"/>
-                    <a:pt x="12443142" y="1861147"/>
-                  </a:cubicBezTo>
-                  <a:cubicBezTo>
-                    <a:pt x="12482512" y="1847177"/>
-                    <a:pt x="12500292" y="1840827"/>
-                    <a:pt x="12533312" y="1834477"/>
-                  </a:cubicBezTo>
-                  <a:cubicBezTo>
-                    <a:pt x="12573952" y="1826857"/>
-                    <a:pt x="12619672" y="1830667"/>
-                    <a:pt x="12669202" y="1821777"/>
-                  </a:cubicBezTo>
-                  <a:cubicBezTo>
-                    <a:pt x="12730162" y="1810347"/>
-                    <a:pt x="12787312" y="1777327"/>
-                    <a:pt x="12873672" y="1764627"/>
-                  </a:cubicBezTo>
-                  <a:cubicBezTo>
-                    <a:pt x="13012102" y="1745577"/>
-                    <a:pt x="13288962" y="1769707"/>
-                    <a:pt x="13423582" y="1757007"/>
-                  </a:cubicBezTo>
-                  <a:cubicBezTo>
-                    <a:pt x="13503593" y="1749387"/>
-                    <a:pt x="13522643" y="1732877"/>
-                    <a:pt x="13612812" y="1725257"/>
-                  </a:cubicBezTo>
-                  <a:cubicBezTo>
-                    <a:pt x="13836332" y="1706207"/>
-                    <a:pt x="14520862" y="1737957"/>
-                    <a:pt x="14786293" y="1718907"/>
-                  </a:cubicBezTo>
-                  <a:cubicBezTo>
-                    <a:pt x="14924721" y="1708747"/>
-                    <a:pt x="15006002" y="1693507"/>
-                    <a:pt x="15097443" y="1675727"/>
-                  </a:cubicBezTo>
-                  <a:cubicBezTo>
-                    <a:pt x="15173643" y="1661757"/>
-                    <a:pt x="15233332" y="1654137"/>
-                    <a:pt x="15303182" y="1628737"/>
-                  </a:cubicBezTo>
-                  <a:cubicBezTo>
-                    <a:pt x="15378112" y="1600797"/>
-                    <a:pt x="15461932" y="1563967"/>
-                    <a:pt x="15533052" y="1511897"/>
-                  </a:cubicBezTo>
-                  <a:cubicBezTo>
-                    <a:pt x="15607982" y="1454747"/>
-                    <a:pt x="15703232" y="1354417"/>
-                    <a:pt x="15736252" y="1294727"/>
-                  </a:cubicBezTo>
-                  <a:cubicBezTo>
-                    <a:pt x="15754032" y="1261707"/>
-                    <a:pt x="15747682" y="1233767"/>
-                    <a:pt x="15757843" y="1207097"/>
-                  </a:cubicBezTo>
-                  <a:cubicBezTo>
-                    <a:pt x="15768002" y="1181697"/>
-                    <a:pt x="15788321" y="1172807"/>
-                    <a:pt x="15797212" y="1138517"/>
-                  </a:cubicBezTo>
-                  <a:cubicBezTo>
-                    <a:pt x="15818802" y="1058507"/>
-                    <a:pt x="15811182" y="800697"/>
-                    <a:pt x="15794671" y="709257"/>
-                  </a:cubicBezTo>
-                  <a:cubicBezTo>
-                    <a:pt x="15787052" y="666077"/>
-                    <a:pt x="15779432" y="641947"/>
-                    <a:pt x="15760382" y="614007"/>
-                  </a:cubicBezTo>
-                  <a:cubicBezTo>
-                    <a:pt x="15740062" y="584797"/>
-                    <a:pt x="15714662" y="563207"/>
-                    <a:pt x="15674021" y="540347"/>
-                  </a:cubicBezTo>
-                  <a:cubicBezTo>
-                    <a:pt x="15599093" y="500977"/>
-                    <a:pt x="15501302" y="462877"/>
-                    <a:pt x="15327312" y="436207"/>
-                  </a:cubicBezTo>
-                  <a:cubicBezTo>
-                    <a:pt x="14848521" y="363817"/>
-                    <a:pt x="13408343" y="420967"/>
-                    <a:pt x="12553632" y="419697"/>
-                  </a:cubicBezTo>
-                  <a:cubicBezTo>
-                    <a:pt x="11818302" y="419697"/>
-                    <a:pt x="10806112" y="440017"/>
-                    <a:pt x="10505122" y="429857"/>
-                  </a:cubicBezTo>
-                  <a:cubicBezTo>
-                    <a:pt x="10418762" y="426047"/>
-                    <a:pt x="10407332" y="427317"/>
-                    <a:pt x="10340022" y="417157"/>
-                  </a:cubicBezTo>
-                  <a:cubicBezTo>
-                    <a:pt x="10229532" y="400647"/>
-                    <a:pt x="10074592" y="348577"/>
-                    <a:pt x="9906952" y="315557"/>
-                  </a:cubicBezTo>
-                  <a:cubicBezTo>
-                    <a:pt x="9677082" y="271107"/>
-                    <a:pt x="9367202" y="206337"/>
-                    <a:pt x="9087802" y="182207"/>
-                  </a:cubicBezTo>
-                  <a:cubicBezTo>
-                    <a:pt x="8798242" y="158077"/>
-                    <a:pt x="8619172" y="174587"/>
-                    <a:pt x="8200072" y="173317"/>
-                  </a:cubicBezTo>
-                  <a:cubicBezTo>
-                    <a:pt x="7185342" y="166967"/>
-                    <a:pt x="3734752" y="113627"/>
-                    <a:pt x="2982912" y="172047"/>
-                  </a:cubicBezTo>
-                  <a:cubicBezTo>
-                    <a:pt x="2774632" y="188557"/>
-                    <a:pt x="2692082" y="211417"/>
-                    <a:pt x="2585402" y="235547"/>
-                  </a:cubicBezTo>
-                  <a:cubicBezTo>
-                    <a:pt x="2511742" y="252057"/>
-                    <a:pt x="2476182" y="274917"/>
-                    <a:pt x="2399982" y="291427"/>
-                  </a:cubicBezTo>
-                  <a:cubicBezTo>
-                    <a:pt x="2285682" y="315557"/>
-                    <a:pt x="2073592" y="324447"/>
-                    <a:pt x="1959292" y="349847"/>
-                  </a:cubicBezTo>
-                  <a:cubicBezTo>
-                    <a:pt x="1883092" y="366357"/>
-                    <a:pt x="1834832" y="393027"/>
-                    <a:pt x="1773872" y="408267"/>
-                  </a:cubicBezTo>
-                  <a:cubicBezTo>
-                    <a:pt x="1716722" y="422237"/>
-                    <a:pt x="1662112" y="431127"/>
-                    <a:pt x="1602422" y="441287"/>
-                  </a:cubicBezTo>
-                  <a:cubicBezTo>
-                    <a:pt x="1537652" y="450177"/>
-                    <a:pt x="1476692" y="461607"/>
-                    <a:pt x="1400492" y="465417"/>
-                  </a:cubicBezTo>
-                  <a:cubicBezTo>
-                    <a:pt x="1298892" y="469227"/>
-                    <a:pt x="1096962" y="479387"/>
-                    <a:pt x="1044892" y="455257"/>
-                  </a:cubicBezTo>
-                  <a:cubicBezTo>
-                    <a:pt x="1025842" y="447637"/>
-                    <a:pt x="1019492" y="434937"/>
-                    <a:pt x="1014412" y="420967"/>
-                  </a:cubicBezTo>
-                  <a:cubicBezTo>
-                    <a:pt x="1009332" y="408267"/>
-                    <a:pt x="1010602" y="387947"/>
-                    <a:pt x="1014412" y="375247"/>
-                  </a:cubicBezTo>
-                  <a:cubicBezTo>
-                    <a:pt x="1018222" y="365087"/>
-                    <a:pt x="1023302" y="356197"/>
-                    <a:pt x="1032192" y="349847"/>
-                  </a:cubicBezTo>
-                  <a:cubicBezTo>
-                    <a:pt x="1042352" y="342227"/>
-                    <a:pt x="1075372" y="333337"/>
-                    <a:pt x="1075372" y="333337"/>
                   </a:cubicBezTo>
                 </a:path>
               </a:pathLst>
@@ -10768,6 +10327,1547 @@
         </p:nvGrpSpPr>
         <p:grpSpPr>
           <a:xfrm rot="0">
+            <a:off x="-3802058" y="-5906380"/>
+            <a:ext cx="22361988" cy="12566000"/>
+            <a:chOff x="0" y="0"/>
+            <a:chExt cx="29815984" cy="16754666"/>
+          </a:xfrm>
+        </p:grpSpPr>
+        <p:pic>
+          <p:nvPicPr>
+            <p:cNvPr name="Picture 8" id="8"/>
+            <p:cNvPicPr>
+              <a:picLocks noChangeAspect="true"/>
+            </p:cNvPicPr>
+            <p:nvPr/>
+          </p:nvPicPr>
+          <p:blipFill>
+            <a:blip r:embed="rId8"/>
+            <a:srcRect l="0" t="3269" r="0" b="3269"/>
+            <a:stretch>
+              <a:fillRect/>
+            </a:stretch>
+          </p:blipFill>
+          <p:spPr>
+            <a:xfrm flipH="false" flipV="false">
+              <a:off x="0" y="0"/>
+              <a:ext cx="29815984" cy="16754666"/>
+            </a:xfrm>
+            <a:prstGeom prst="rect">
+              <a:avLst/>
+            </a:prstGeom>
+          </p:spPr>
+        </p:pic>
+      </p:grpSp>
+      <p:sp>
+        <p:nvSpPr>
+          <p:cNvPr name="Freeform 9" id="9"/>
+          <p:cNvSpPr/>
+          <p:nvPr/>
+        </p:nvSpPr>
+        <p:spPr>
+          <a:xfrm flipH="false" flipV="false" rot="0">
+            <a:off x="0" y="6456064"/>
+            <a:ext cx="19702881" cy="20034489"/>
+          </a:xfrm>
+          <a:custGeom>
+            <a:avLst/>
+            <a:gdLst/>
+            <a:ahLst/>
+            <a:cxnLst/>
+            <a:rect r="r" b="b" t="t" l="l"/>
+            <a:pathLst>
+              <a:path h="20034489" w="19702881">
+                <a:moveTo>
+                  <a:pt x="0" y="0"/>
+                </a:moveTo>
+                <a:lnTo>
+                  <a:pt x="19702881" y="0"/>
+                </a:lnTo>
+                <a:lnTo>
+                  <a:pt x="19702881" y="20034489"/>
+                </a:lnTo>
+                <a:lnTo>
+                  <a:pt x="0" y="20034489"/>
+                </a:lnTo>
+                <a:lnTo>
+                  <a:pt x="0" y="0"/>
+                </a:lnTo>
+                <a:close/>
+              </a:path>
+            </a:pathLst>
+          </a:custGeom>
+          <a:blipFill>
+            <a:blip r:embed="rId9"/>
+            <a:stretch>
+              <a:fillRect l="-47811" t="0" r="-46555" b="0"/>
+            </a:stretch>
+          </a:blipFill>
+        </p:spPr>
+      </p:sp>
+      <p:sp>
+        <p:nvSpPr>
+          <p:cNvPr name="TextBox 10" id="10"/>
+          <p:cNvSpPr txBox="true"/>
+          <p:nvPr/>
+        </p:nvSpPr>
+        <p:spPr>
+          <a:xfrm rot="0">
+            <a:off x="9518477" y="5881523"/>
+            <a:ext cx="8377025" cy="3669283"/>
+          </a:xfrm>
+          <a:prstGeom prst="rect">
+            <a:avLst/>
+          </a:prstGeom>
+        </p:spPr>
+        <p:txBody>
+          <a:bodyPr anchor="t" rtlCol="false" tIns="0" lIns="0" bIns="0" rIns="0">
+            <a:spAutoFit/>
+          </a:bodyPr>
+          <a:lstStyle/>
+          <a:p>
+            <a:pPr algn="l" marL="702495" indent="-351247" lvl="1">
+              <a:lnSpc>
+                <a:spcPts val="4880"/>
+              </a:lnSpc>
+              <a:buFont typeface="Arial"/>
+              <a:buChar char="•"/>
+            </a:pPr>
+            <a:r>
+              <a:rPr lang="en-US" b="true" sz="3253">
+                <a:solidFill>
+                  <a:srgbClr val="FFFFFF"/>
+                </a:solidFill>
+                <a:latin typeface="Garet Bold"/>
+                <a:ea typeface="Garet Bold"/>
+                <a:cs typeface="Garet Bold"/>
+                <a:sym typeface="Garet Bold"/>
+              </a:rPr>
+              <a:t>Após a escolha, envia a matriz o número do jogador para uma função conferir se o jogo foi ganho após a escolha feita</a:t>
+            </a:r>
+          </a:p>
+          <a:p>
+            <a:pPr algn="l" marL="702495" indent="-351247" lvl="1">
+              <a:lnSpc>
+                <a:spcPts val="4880"/>
+              </a:lnSpc>
+              <a:spcBef>
+                <a:spcPct val="0"/>
+              </a:spcBef>
+              <a:buFont typeface="Arial"/>
+              <a:buChar char="•"/>
+            </a:pPr>
+            <a:r>
+              <a:rPr lang="en-US" b="true" sz="3253">
+                <a:solidFill>
+                  <a:srgbClr val="FFFFFF"/>
+                </a:solidFill>
+                <a:latin typeface="Garet Bold"/>
+                <a:ea typeface="Garet Bold"/>
+                <a:cs typeface="Garet Bold"/>
+                <a:sym typeface="Garet Bold"/>
+              </a:rPr>
+              <a:t>Se o jogo não tiver sido ganho, passa a vez para o próximo jogador</a:t>
+            </a:r>
+          </a:p>
+        </p:txBody>
+      </p:sp>
+      <p:sp>
+        <p:nvSpPr>
+          <p:cNvPr name="Freeform 11" id="11"/>
+          <p:cNvSpPr/>
+          <p:nvPr/>
+        </p:nvSpPr>
+        <p:spPr>
+          <a:xfrm flipH="false" flipV="false" rot="0">
+            <a:off x="-1142950" y="-17500280"/>
+            <a:ext cx="19702881" cy="18128006"/>
+          </a:xfrm>
+          <a:custGeom>
+            <a:avLst/>
+            <a:gdLst/>
+            <a:ahLst/>
+            <a:cxnLst/>
+            <a:rect r="r" b="b" t="t" l="l"/>
+            <a:pathLst>
+              <a:path h="18128006" w="19702881">
+                <a:moveTo>
+                  <a:pt x="0" y="0"/>
+                </a:moveTo>
+                <a:lnTo>
+                  <a:pt x="19702880" y="0"/>
+                </a:lnTo>
+                <a:lnTo>
+                  <a:pt x="19702880" y="18128006"/>
+                </a:lnTo>
+                <a:lnTo>
+                  <a:pt x="0" y="18128006"/>
+                </a:lnTo>
+                <a:lnTo>
+                  <a:pt x="0" y="0"/>
+                </a:lnTo>
+                <a:close/>
+              </a:path>
+            </a:pathLst>
+          </a:custGeom>
+          <a:blipFill>
+            <a:blip r:embed="rId9"/>
+            <a:stretch>
+              <a:fillRect l="-38504" t="0" r="-37367" b="0"/>
+            </a:stretch>
+          </a:blipFill>
+        </p:spPr>
+      </p:sp>
+      <p:sp>
+        <p:nvSpPr>
+          <p:cNvPr name="Freeform 12" id="12"/>
+          <p:cNvSpPr/>
+          <p:nvPr/>
+        </p:nvSpPr>
+        <p:spPr>
+          <a:xfrm flipH="false" flipV="false" rot="0">
+            <a:off x="17505033" y="-852337"/>
+            <a:ext cx="19702881" cy="17232253"/>
+          </a:xfrm>
+          <a:custGeom>
+            <a:avLst/>
+            <a:gdLst/>
+            <a:ahLst/>
+            <a:cxnLst/>
+            <a:rect r="r" b="b" t="t" l="l"/>
+            <a:pathLst>
+              <a:path h="17232253" w="19702881">
+                <a:moveTo>
+                  <a:pt x="0" y="0"/>
+                </a:moveTo>
+                <a:lnTo>
+                  <a:pt x="19702881" y="0"/>
+                </a:lnTo>
+                <a:lnTo>
+                  <a:pt x="19702881" y="17232253"/>
+                </a:lnTo>
+                <a:lnTo>
+                  <a:pt x="0" y="17232253"/>
+                </a:lnTo>
+                <a:lnTo>
+                  <a:pt x="0" y="0"/>
+                </a:lnTo>
+                <a:close/>
+              </a:path>
+            </a:pathLst>
+          </a:custGeom>
+          <a:blipFill>
+            <a:blip r:embed="rId9"/>
+            <a:stretch>
+              <a:fillRect l="-34130" t="0" r="-33050" b="0"/>
+            </a:stretch>
+          </a:blipFill>
+        </p:spPr>
+      </p:sp>
+      <p:grpSp>
+        <p:nvGrpSpPr>
+          <p:cNvPr name="Group 13" id="13"/>
+          <p:cNvGrpSpPr/>
+          <p:nvPr/>
+        </p:nvGrpSpPr>
+        <p:grpSpPr>
+          <a:xfrm rot="0">
+            <a:off x="1226820" y="2727008"/>
+            <a:ext cx="12044362" cy="3299460"/>
+            <a:chOff x="0" y="0"/>
+            <a:chExt cx="16059150" cy="4399280"/>
+          </a:xfrm>
+        </p:grpSpPr>
+        <p:sp>
+          <p:nvSpPr>
+            <p:cNvPr name="Freeform 14" id="14"/>
+            <p:cNvSpPr/>
+            <p:nvPr/>
+          </p:nvSpPr>
+          <p:spPr>
+            <a:xfrm flipH="false" flipV="false" rot="0">
+              <a:off x="44768" y="27343"/>
+              <a:ext cx="15969381" cy="4323467"/>
+            </a:xfrm>
+            <a:custGeom>
+              <a:avLst/>
+              <a:gdLst/>
+              <a:ahLst/>
+              <a:cxnLst/>
+              <a:rect r="r" b="b" t="t" l="l"/>
+              <a:pathLst>
+                <a:path h="4323467" w="15969381">
+                  <a:moveTo>
+                    <a:pt x="1075372" y="333337"/>
+                  </a:moveTo>
+                  <a:cubicBezTo>
+                    <a:pt x="1471612" y="328257"/>
+                    <a:pt x="1527492" y="321907"/>
+                    <a:pt x="1588452" y="314287"/>
+                  </a:cubicBezTo>
+                  <a:cubicBezTo>
+                    <a:pt x="1645602" y="306667"/>
+                    <a:pt x="1697672" y="299047"/>
+                    <a:pt x="1752282" y="286347"/>
+                  </a:cubicBezTo>
+                  <a:cubicBezTo>
+                    <a:pt x="1809432" y="272377"/>
+                    <a:pt x="1851342" y="249517"/>
+                    <a:pt x="1922462" y="234277"/>
+                  </a:cubicBezTo>
+                  <a:cubicBezTo>
+                    <a:pt x="2038032" y="208877"/>
+                    <a:pt x="2267902" y="198717"/>
+                    <a:pt x="2382202" y="174587"/>
+                  </a:cubicBezTo>
+                  <a:cubicBezTo>
+                    <a:pt x="2453322" y="159347"/>
+                    <a:pt x="2482532" y="139027"/>
+                    <a:pt x="2552382" y="122517"/>
+                  </a:cubicBezTo>
+                  <a:cubicBezTo>
+                    <a:pt x="2660332" y="98387"/>
+                    <a:pt x="2780982" y="70447"/>
+                    <a:pt x="2970212" y="52667"/>
+                  </a:cubicBezTo>
+                  <a:cubicBezTo>
+                    <a:pt x="3366452" y="18377"/>
+                    <a:pt x="4247832" y="33617"/>
+                    <a:pt x="4815522" y="32347"/>
+                  </a:cubicBezTo>
+                  <a:cubicBezTo>
+                    <a:pt x="5303202" y="31077"/>
+                    <a:pt x="5635942" y="42507"/>
+                    <a:pt x="6174422" y="42507"/>
+                  </a:cubicBezTo>
+                  <a:cubicBezTo>
+                    <a:pt x="6963092" y="42507"/>
+                    <a:pt x="8465502" y="-38773"/>
+                    <a:pt x="9090342" y="23457"/>
+                  </a:cubicBezTo>
+                  <a:cubicBezTo>
+                    <a:pt x="9390062" y="53937"/>
+                    <a:pt x="9600882" y="137757"/>
+                    <a:pt x="9749472" y="160617"/>
+                  </a:cubicBezTo>
+                  <a:cubicBezTo>
+                    <a:pt x="9823132" y="172047"/>
+                    <a:pt x="9849802" y="165697"/>
+                    <a:pt x="9915842" y="177127"/>
+                  </a:cubicBezTo>
+                  <a:cubicBezTo>
+                    <a:pt x="10016172" y="194907"/>
+                    <a:pt x="10176192" y="254597"/>
+                    <a:pt x="10285412" y="272377"/>
+                  </a:cubicBezTo>
+                  <a:cubicBezTo>
+                    <a:pt x="10367962" y="286347"/>
+                    <a:pt x="10397172" y="285077"/>
+                    <a:pt x="10510202" y="290157"/>
+                  </a:cubicBezTo>
+                  <a:cubicBezTo>
+                    <a:pt x="10849292" y="304127"/>
+                    <a:pt x="11819572" y="302857"/>
+                    <a:pt x="12553632" y="302857"/>
+                  </a:cubicBezTo>
+                  <a:cubicBezTo>
+                    <a:pt x="13408343" y="304127"/>
+                    <a:pt x="14957743" y="253327"/>
+                    <a:pt x="15331121" y="286347"/>
+                  </a:cubicBezTo>
+                  <a:cubicBezTo>
+                    <a:pt x="15426371" y="295237"/>
+                    <a:pt x="15444152" y="301587"/>
+                    <a:pt x="15508921" y="319367"/>
+                  </a:cubicBezTo>
+                  <a:cubicBezTo>
+                    <a:pt x="15588932" y="342227"/>
+                    <a:pt x="15709582" y="384137"/>
+                    <a:pt x="15773082" y="420967"/>
+                  </a:cubicBezTo>
+                  <a:cubicBezTo>
+                    <a:pt x="15816262" y="446367"/>
+                    <a:pt x="15841662" y="464147"/>
+                    <a:pt x="15869602" y="500977"/>
+                  </a:cubicBezTo>
+                  <a:cubicBezTo>
+                    <a:pt x="15903893" y="545427"/>
+                    <a:pt x="15933102" y="607657"/>
+                    <a:pt x="15950882" y="681317"/>
+                  </a:cubicBezTo>
+                  <a:cubicBezTo>
+                    <a:pt x="15975012" y="789267"/>
+                    <a:pt x="15971202" y="993737"/>
+                    <a:pt x="15963582" y="1094067"/>
+                  </a:cubicBezTo>
+                  <a:cubicBezTo>
+                    <a:pt x="15958502" y="1151217"/>
+                    <a:pt x="15949612" y="1188047"/>
+                    <a:pt x="15936912" y="1228687"/>
+                  </a:cubicBezTo>
+                  <a:cubicBezTo>
+                    <a:pt x="15925482" y="1265517"/>
+                    <a:pt x="15908971" y="1299807"/>
+                    <a:pt x="15896271" y="1329017"/>
+                  </a:cubicBezTo>
+                  <a:cubicBezTo>
+                    <a:pt x="15883571" y="1355687"/>
+                    <a:pt x="15875952" y="1376007"/>
+                    <a:pt x="15860712" y="1400137"/>
+                  </a:cubicBezTo>
+                  <a:cubicBezTo>
+                    <a:pt x="15840393" y="1430617"/>
+                    <a:pt x="15808643" y="1466177"/>
+                    <a:pt x="15781971" y="1495387"/>
+                  </a:cubicBezTo>
+                  <a:cubicBezTo>
+                    <a:pt x="15757843" y="1523327"/>
+                    <a:pt x="15733712" y="1549997"/>
+                    <a:pt x="15705771" y="1574127"/>
+                  </a:cubicBezTo>
+                  <a:cubicBezTo>
+                    <a:pt x="15674021" y="1600797"/>
+                    <a:pt x="15643543" y="1621117"/>
+                    <a:pt x="15600362" y="1647787"/>
+                  </a:cubicBezTo>
+                  <a:cubicBezTo>
+                    <a:pt x="15540671" y="1684617"/>
+                    <a:pt x="15456852" y="1741767"/>
+                    <a:pt x="15378112" y="1772247"/>
+                  </a:cubicBezTo>
+                  <a:cubicBezTo>
+                    <a:pt x="15295562" y="1805267"/>
+                    <a:pt x="15201582" y="1819237"/>
+                    <a:pt x="15116493" y="1837017"/>
+                  </a:cubicBezTo>
+                  <a:cubicBezTo>
+                    <a:pt x="15033943" y="1853527"/>
+                    <a:pt x="14988221" y="1864957"/>
+                    <a:pt x="14875193" y="1873847"/>
+                  </a:cubicBezTo>
+                  <a:cubicBezTo>
+                    <a:pt x="14619921" y="1894167"/>
+                    <a:pt x="13841412" y="1858607"/>
+                    <a:pt x="13614082" y="1877657"/>
+                  </a:cubicBezTo>
+                  <a:cubicBezTo>
+                    <a:pt x="13528993" y="1885277"/>
+                    <a:pt x="13515021" y="1900517"/>
+                    <a:pt x="13440093" y="1906867"/>
+                  </a:cubicBezTo>
+                  <a:cubicBezTo>
+                    <a:pt x="13305471" y="1918297"/>
+                    <a:pt x="13003212" y="1891627"/>
+                    <a:pt x="12874942" y="1911947"/>
+                  </a:cubicBezTo>
+                  <a:cubicBezTo>
+                    <a:pt x="12805092" y="1922107"/>
+                    <a:pt x="12772072" y="1946237"/>
+                    <a:pt x="12717462" y="1957667"/>
+                  </a:cubicBezTo>
+                  <a:cubicBezTo>
+                    <a:pt x="12661582" y="1970367"/>
+                    <a:pt x="12613322" y="1964017"/>
+                    <a:pt x="12544742" y="1981797"/>
+                  </a:cubicBezTo>
+                  <a:cubicBezTo>
+                    <a:pt x="12435522" y="2008467"/>
+                    <a:pt x="12242482" y="2102447"/>
+                    <a:pt x="12130722" y="2136737"/>
+                  </a:cubicBezTo>
+                  <a:cubicBezTo>
+                    <a:pt x="12059602" y="2158327"/>
+                    <a:pt x="11997372" y="2159597"/>
+                    <a:pt x="11949112" y="2181187"/>
+                  </a:cubicBezTo>
+                  <a:cubicBezTo>
+                    <a:pt x="11913552" y="2198967"/>
+                    <a:pt x="11895772" y="2229447"/>
+                    <a:pt x="11864022" y="2244687"/>
+                  </a:cubicBezTo>
+                  <a:cubicBezTo>
+                    <a:pt x="11829732" y="2261197"/>
+                    <a:pt x="11792902" y="2259927"/>
+                    <a:pt x="11750992" y="2277707"/>
+                  </a:cubicBezTo>
+                  <a:cubicBezTo>
+                    <a:pt x="11692572" y="2300567"/>
+                    <a:pt x="11603672" y="2346287"/>
+                    <a:pt x="11550332" y="2381847"/>
+                  </a:cubicBezTo>
+                  <a:cubicBezTo>
+                    <a:pt x="11510962" y="2408517"/>
+                    <a:pt x="11486832" y="2444077"/>
+                    <a:pt x="11453812" y="2463127"/>
+                  </a:cubicBezTo>
+                  <a:cubicBezTo>
+                    <a:pt x="11424602" y="2479637"/>
+                    <a:pt x="11392852" y="2478367"/>
+                    <a:pt x="11366182" y="2493607"/>
+                  </a:cubicBezTo>
+                  <a:cubicBezTo>
+                    <a:pt x="11336972" y="2510117"/>
+                    <a:pt x="11317922" y="2540597"/>
+                    <a:pt x="11288712" y="2559647"/>
+                  </a:cubicBezTo>
+                  <a:cubicBezTo>
+                    <a:pt x="11253152" y="2579967"/>
+                    <a:pt x="11211242" y="2585047"/>
+                    <a:pt x="11168062" y="2609177"/>
+                  </a:cubicBezTo>
+                  <a:cubicBezTo>
+                    <a:pt x="11109642" y="2642197"/>
+                    <a:pt x="11041062" y="2713317"/>
+                    <a:pt x="10975022" y="2752687"/>
+                  </a:cubicBezTo>
+                  <a:cubicBezTo>
+                    <a:pt x="10914062" y="2788247"/>
+                    <a:pt x="10837862" y="2808567"/>
+                    <a:pt x="10787062" y="2837777"/>
+                  </a:cubicBezTo>
+                  <a:cubicBezTo>
+                    <a:pt x="10748962" y="2859367"/>
+                    <a:pt x="10718482" y="2879687"/>
+                    <a:pt x="10693082" y="2902547"/>
+                  </a:cubicBezTo>
+                  <a:cubicBezTo>
+                    <a:pt x="10672762" y="2921597"/>
+                    <a:pt x="10667682" y="2940647"/>
+                    <a:pt x="10643552" y="2962237"/>
+                  </a:cubicBezTo>
+                  <a:cubicBezTo>
+                    <a:pt x="10602912" y="2995257"/>
+                    <a:pt x="10525442" y="3034627"/>
+                    <a:pt x="10460672" y="3068917"/>
+                  </a:cubicBezTo>
+                  <a:cubicBezTo>
+                    <a:pt x="10392092" y="3107017"/>
+                    <a:pt x="10318432" y="3146387"/>
+                    <a:pt x="10240962" y="3178137"/>
+                  </a:cubicBezTo>
+                  <a:cubicBezTo>
+                    <a:pt x="10160952" y="3211157"/>
+                    <a:pt x="10063162" y="3228937"/>
+                    <a:pt x="9985692" y="3261957"/>
+                  </a:cubicBezTo>
+                  <a:cubicBezTo>
+                    <a:pt x="9915842" y="3291167"/>
+                    <a:pt x="9848532" y="3341967"/>
+                    <a:pt x="9796462" y="3361017"/>
+                  </a:cubicBezTo>
+                  <a:cubicBezTo>
+                    <a:pt x="9762172" y="3374987"/>
+                    <a:pt x="9738042" y="3378797"/>
+                    <a:pt x="9706292" y="3382607"/>
+                  </a:cubicBezTo>
+                  <a:cubicBezTo>
+                    <a:pt x="9673272" y="3387687"/>
+                    <a:pt x="9650412" y="3382607"/>
+                    <a:pt x="9603422" y="3388957"/>
+                  </a:cubicBezTo>
+                  <a:cubicBezTo>
+                    <a:pt x="9505632" y="3402927"/>
+                    <a:pt x="9261792" y="3479127"/>
+                    <a:pt x="9152572" y="3494367"/>
+                  </a:cubicBezTo>
+                  <a:cubicBezTo>
+                    <a:pt x="9091612" y="3501987"/>
+                    <a:pt x="9056052" y="3489287"/>
+                    <a:pt x="9009062" y="3500717"/>
+                  </a:cubicBezTo>
+                  <a:cubicBezTo>
+                    <a:pt x="8959532" y="3510877"/>
+                    <a:pt x="8939212" y="3537547"/>
+                    <a:pt x="8865552" y="3560407"/>
+                  </a:cubicBezTo>
+                  <a:cubicBezTo>
+                    <a:pt x="8647112" y="3626447"/>
+                    <a:pt x="7821612" y="3790277"/>
+                    <a:pt x="7530782" y="3824567"/>
+                  </a:cubicBezTo>
+                  <a:cubicBezTo>
+                    <a:pt x="7389812" y="3841077"/>
+                    <a:pt x="7284402" y="3822027"/>
+                    <a:pt x="7215822" y="3835997"/>
+                  </a:cubicBezTo>
+                  <a:cubicBezTo>
+                    <a:pt x="7181532" y="3843617"/>
+                    <a:pt x="7175182" y="3858857"/>
+                    <a:pt x="7140892" y="3865207"/>
+                  </a:cubicBezTo>
+                  <a:cubicBezTo>
+                    <a:pt x="7074852" y="3879177"/>
+                    <a:pt x="6945312" y="3860127"/>
+                    <a:pt x="6846252" y="3872827"/>
+                  </a:cubicBezTo>
+                  <a:cubicBezTo>
+                    <a:pt x="6744652" y="3886797"/>
+                    <a:pt x="6644322" y="3932517"/>
+                    <a:pt x="6541452" y="3945217"/>
+                  </a:cubicBezTo>
+                  <a:cubicBezTo>
+                    <a:pt x="6441122" y="3957917"/>
+                    <a:pt x="6328092" y="3941407"/>
+                    <a:pt x="6235382" y="3950297"/>
+                  </a:cubicBezTo>
+                  <a:cubicBezTo>
+                    <a:pt x="6159182" y="3956647"/>
+                    <a:pt x="6086792" y="3978237"/>
+                    <a:pt x="6024562" y="3983317"/>
+                  </a:cubicBezTo>
+                  <a:cubicBezTo>
+                    <a:pt x="5976302" y="3987127"/>
+                    <a:pt x="5934392" y="3974427"/>
+                    <a:pt x="5895022" y="3984587"/>
+                  </a:cubicBezTo>
+                  <a:cubicBezTo>
+                    <a:pt x="5856922" y="3994747"/>
+                    <a:pt x="5835332" y="4025227"/>
+                    <a:pt x="5792152" y="4041737"/>
+                  </a:cubicBezTo>
+                  <a:cubicBezTo>
+                    <a:pt x="5728652" y="4064597"/>
+                    <a:pt x="5675312" y="4079837"/>
+                    <a:pt x="5547042" y="4092537"/>
+                  </a:cubicBezTo>
+                  <a:cubicBezTo>
+                    <a:pt x="5086032" y="4140797"/>
+                    <a:pt x="2887662" y="4048087"/>
+                    <a:pt x="2358072" y="4098887"/>
+                  </a:cubicBezTo>
+                  <a:cubicBezTo>
+                    <a:pt x="2180272" y="4116667"/>
+                    <a:pt x="2126932" y="4136987"/>
+                    <a:pt x="2003742" y="4167467"/>
+                  </a:cubicBezTo>
+                  <a:cubicBezTo>
+                    <a:pt x="1866582" y="4200487"/>
+                    <a:pt x="1688782" y="4271607"/>
+                    <a:pt x="1570672" y="4294467"/>
+                  </a:cubicBezTo>
+                  <a:cubicBezTo>
+                    <a:pt x="1491932" y="4310977"/>
+                    <a:pt x="1443672" y="4312247"/>
+                    <a:pt x="1370012" y="4316057"/>
+                  </a:cubicBezTo>
+                  <a:cubicBezTo>
+                    <a:pt x="1279842" y="4321137"/>
+                    <a:pt x="1143952" y="4321137"/>
+                    <a:pt x="1065212" y="4319867"/>
+                  </a:cubicBezTo>
+                  <a:cubicBezTo>
+                    <a:pt x="1016952" y="4319867"/>
+                    <a:pt x="982662" y="4328757"/>
+                    <a:pt x="945832" y="4318597"/>
+                  </a:cubicBezTo>
+                  <a:cubicBezTo>
+                    <a:pt x="910272" y="4308437"/>
+                    <a:pt x="877252" y="4283037"/>
+                    <a:pt x="848042" y="4261447"/>
+                  </a:cubicBezTo>
+                  <a:cubicBezTo>
+                    <a:pt x="820102" y="4241127"/>
+                    <a:pt x="799782" y="4225887"/>
+                    <a:pt x="773112" y="4192867"/>
+                  </a:cubicBezTo>
+                  <a:cubicBezTo>
+                    <a:pt x="729932" y="4135717"/>
+                    <a:pt x="680402" y="4034117"/>
+                    <a:pt x="632142" y="3935057"/>
+                  </a:cubicBezTo>
+                  <a:cubicBezTo>
+                    <a:pt x="568642" y="3804247"/>
+                    <a:pt x="497522" y="3634067"/>
+                    <a:pt x="432752" y="3471507"/>
+                  </a:cubicBezTo>
+                  <a:cubicBezTo>
+                    <a:pt x="362902" y="3293707"/>
+                    <a:pt x="295592" y="3073997"/>
+                    <a:pt x="232092" y="2905087"/>
+                  </a:cubicBezTo>
+                  <a:cubicBezTo>
+                    <a:pt x="178752" y="2766657"/>
+                    <a:pt x="115252" y="2656167"/>
+                    <a:pt x="78422" y="2529167"/>
+                  </a:cubicBezTo>
+                  <a:cubicBezTo>
+                    <a:pt x="44132" y="2407247"/>
+                    <a:pt x="25082" y="2294217"/>
+                    <a:pt x="12382" y="2158327"/>
+                  </a:cubicBezTo>
+                  <a:cubicBezTo>
+                    <a:pt x="-2858" y="1994497"/>
+                    <a:pt x="-2858" y="1734147"/>
+                    <a:pt x="6032" y="1613497"/>
+                  </a:cubicBezTo>
+                  <a:cubicBezTo>
+                    <a:pt x="11112" y="1552537"/>
+                    <a:pt x="25082" y="1532217"/>
+                    <a:pt x="30162" y="1476337"/>
+                  </a:cubicBezTo>
+                  <a:cubicBezTo>
+                    <a:pt x="40322" y="1389977"/>
+                    <a:pt x="36512" y="1228687"/>
+                    <a:pt x="45402" y="1144867"/>
+                  </a:cubicBezTo>
+                  <a:cubicBezTo>
+                    <a:pt x="51752" y="1092797"/>
+                    <a:pt x="58102" y="1057237"/>
+                    <a:pt x="69532" y="1020407"/>
+                  </a:cubicBezTo>
+                  <a:cubicBezTo>
+                    <a:pt x="78422" y="989927"/>
+                    <a:pt x="87312" y="970877"/>
+                    <a:pt x="103822" y="937857"/>
+                  </a:cubicBezTo>
+                  <a:cubicBezTo>
+                    <a:pt x="129222" y="881977"/>
+                    <a:pt x="177482" y="777837"/>
+                    <a:pt x="215582" y="723227"/>
+                  </a:cubicBezTo>
+                  <a:cubicBezTo>
+                    <a:pt x="242252" y="683857"/>
+                    <a:pt x="266382" y="652107"/>
+                    <a:pt x="296862" y="631787"/>
+                  </a:cubicBezTo>
+                  <a:cubicBezTo>
+                    <a:pt x="323532" y="612737"/>
+                    <a:pt x="352742" y="612737"/>
+                    <a:pt x="383222" y="597497"/>
+                  </a:cubicBezTo>
+                  <a:cubicBezTo>
+                    <a:pt x="417512" y="579717"/>
+                    <a:pt x="442912" y="554317"/>
+                    <a:pt x="491172" y="528917"/>
+                  </a:cubicBezTo>
+                  <a:cubicBezTo>
+                    <a:pt x="578802" y="484467"/>
+                    <a:pt x="729932" y="401917"/>
+                    <a:pt x="870902" y="371437"/>
+                  </a:cubicBezTo>
+                  <a:cubicBezTo>
+                    <a:pt x="1030922" y="337147"/>
+                    <a:pt x="1315402" y="334607"/>
+                    <a:pt x="1408112" y="356197"/>
+                  </a:cubicBezTo>
+                  <a:cubicBezTo>
+                    <a:pt x="1441132" y="363817"/>
+                    <a:pt x="1461452" y="372707"/>
+                    <a:pt x="1472882" y="390487"/>
+                  </a:cubicBezTo>
+                  <a:cubicBezTo>
+                    <a:pt x="1485582" y="408267"/>
+                    <a:pt x="1489392" y="443827"/>
+                    <a:pt x="1481772" y="465417"/>
+                  </a:cubicBezTo>
+                  <a:cubicBezTo>
+                    <a:pt x="1472882" y="485737"/>
+                    <a:pt x="1446212" y="508597"/>
+                    <a:pt x="1424622" y="513677"/>
+                  </a:cubicBezTo>
+                  <a:cubicBezTo>
+                    <a:pt x="1403032" y="517487"/>
+                    <a:pt x="1368742" y="508597"/>
+                    <a:pt x="1352232" y="493357"/>
+                  </a:cubicBezTo>
+                  <a:cubicBezTo>
+                    <a:pt x="1336992" y="478117"/>
+                    <a:pt x="1325562" y="443827"/>
+                    <a:pt x="1329372" y="422237"/>
+                  </a:cubicBezTo>
+                  <a:cubicBezTo>
+                    <a:pt x="1331912" y="400647"/>
+                    <a:pt x="1356042" y="372707"/>
+                    <a:pt x="1373822" y="362547"/>
+                  </a:cubicBezTo>
+                  <a:cubicBezTo>
+                    <a:pt x="1389062" y="354927"/>
+                    <a:pt x="1408112" y="352387"/>
+                    <a:pt x="1424622" y="357467"/>
+                  </a:cubicBezTo>
+                  <a:cubicBezTo>
+                    <a:pt x="1444942" y="363817"/>
+                    <a:pt x="1472882" y="387947"/>
+                    <a:pt x="1481772" y="405727"/>
+                  </a:cubicBezTo>
+                  <a:cubicBezTo>
+                    <a:pt x="1489392" y="420967"/>
+                    <a:pt x="1490662" y="440017"/>
+                    <a:pt x="1484312" y="456527"/>
+                  </a:cubicBezTo>
+                  <a:cubicBezTo>
+                    <a:pt x="1476692" y="475577"/>
+                    <a:pt x="1462722" y="497167"/>
+                    <a:pt x="1433512" y="511137"/>
+                  </a:cubicBezTo>
+                  <a:cubicBezTo>
+                    <a:pt x="1352232" y="546697"/>
+                    <a:pt x="1061402" y="492087"/>
+                    <a:pt x="912812" y="518757"/>
+                  </a:cubicBezTo>
+                  <a:cubicBezTo>
+                    <a:pt x="795972" y="541617"/>
+                    <a:pt x="701992" y="587337"/>
+                    <a:pt x="608012" y="631787"/>
+                  </a:cubicBezTo>
+                  <a:cubicBezTo>
+                    <a:pt x="520382" y="672427"/>
+                    <a:pt x="417512" y="729577"/>
+                    <a:pt x="366712" y="772757"/>
+                  </a:cubicBezTo>
+                  <a:cubicBezTo>
+                    <a:pt x="337502" y="796887"/>
+                    <a:pt x="328612" y="810857"/>
+                    <a:pt x="308292" y="842607"/>
+                  </a:cubicBezTo>
+                  <a:cubicBezTo>
+                    <a:pt x="275272" y="892137"/>
+                    <a:pt x="223202" y="991197"/>
+                    <a:pt x="202882" y="1048347"/>
+                  </a:cubicBezTo>
+                  <a:cubicBezTo>
+                    <a:pt x="188912" y="1086447"/>
+                    <a:pt x="186372" y="1106767"/>
+                    <a:pt x="182562" y="1147407"/>
+                  </a:cubicBezTo>
+                  <a:cubicBezTo>
+                    <a:pt x="176212" y="1207097"/>
+                    <a:pt x="182562" y="1299807"/>
+                    <a:pt x="177482" y="1376007"/>
+                  </a:cubicBezTo>
+                  <a:cubicBezTo>
+                    <a:pt x="172402" y="1454747"/>
+                    <a:pt x="155892" y="1518247"/>
+                    <a:pt x="150812" y="1613497"/>
+                  </a:cubicBezTo>
+                  <a:cubicBezTo>
+                    <a:pt x="141922" y="1757007"/>
+                    <a:pt x="147002" y="2027517"/>
+                    <a:pt x="152082" y="2148167"/>
+                  </a:cubicBezTo>
+                  <a:cubicBezTo>
+                    <a:pt x="154622" y="2210397"/>
+                    <a:pt x="157162" y="2239607"/>
+                    <a:pt x="163512" y="2289137"/>
+                  </a:cubicBezTo>
+                  <a:cubicBezTo>
+                    <a:pt x="173672" y="2350097"/>
+                    <a:pt x="180022" y="2397087"/>
+                    <a:pt x="206692" y="2484717"/>
+                  </a:cubicBezTo>
+                  <a:cubicBezTo>
+                    <a:pt x="263842" y="2680297"/>
+                    <a:pt x="441642" y="3143847"/>
+                    <a:pt x="553402" y="3409277"/>
+                  </a:cubicBezTo>
+                  <a:cubicBezTo>
+                    <a:pt x="641032" y="3615017"/>
+                    <a:pt x="747712" y="3830917"/>
+                    <a:pt x="808672" y="3947757"/>
+                  </a:cubicBezTo>
+                  <a:cubicBezTo>
+                    <a:pt x="840422" y="4007447"/>
+                    <a:pt x="853122" y="4043007"/>
+                    <a:pt x="884872" y="4078567"/>
+                  </a:cubicBezTo>
+                  <a:cubicBezTo>
+                    <a:pt x="915352" y="4110317"/>
+                    <a:pt x="940752" y="4138257"/>
+                    <a:pt x="991552" y="4154767"/>
+                  </a:cubicBezTo>
+                  <a:cubicBezTo>
+                    <a:pt x="1081722" y="4183977"/>
+                    <a:pt x="1307782" y="4161117"/>
+                    <a:pt x="1404302" y="4156037"/>
+                  </a:cubicBezTo>
+                  <a:cubicBezTo>
+                    <a:pt x="1457642" y="4152227"/>
+                    <a:pt x="1477962" y="4152227"/>
+                    <a:pt x="1526222" y="4142067"/>
+                  </a:cubicBezTo>
+                  <a:cubicBezTo>
+                    <a:pt x="1601152" y="4124287"/>
+                    <a:pt x="1734502" y="4058247"/>
+                    <a:pt x="1806892" y="4044277"/>
+                  </a:cubicBezTo>
+                  <a:cubicBezTo>
+                    <a:pt x="1850072" y="4035387"/>
+                    <a:pt x="1869122" y="4046817"/>
+                    <a:pt x="1912302" y="4039197"/>
+                  </a:cubicBezTo>
+                  <a:cubicBezTo>
+                    <a:pt x="1982152" y="4027767"/>
+                    <a:pt x="2102802" y="3976967"/>
+                    <a:pt x="2184082" y="3959187"/>
+                  </a:cubicBezTo>
+                  <a:cubicBezTo>
+                    <a:pt x="2247582" y="3945217"/>
+                    <a:pt x="2262822" y="3940137"/>
+                    <a:pt x="2358072" y="3933787"/>
+                  </a:cubicBezTo>
+                  <a:cubicBezTo>
+                    <a:pt x="2759392" y="3905847"/>
+                    <a:pt x="5232082" y="3954107"/>
+                    <a:pt x="5530532" y="3933787"/>
+                  </a:cubicBezTo>
+                  <a:cubicBezTo>
+                    <a:pt x="5581332" y="3931247"/>
+                    <a:pt x="5580062" y="3929977"/>
+                    <a:pt x="5616892" y="3922357"/>
+                  </a:cubicBezTo>
+                  <a:cubicBezTo>
+                    <a:pt x="5693092" y="3907117"/>
+                    <a:pt x="5867082" y="3839807"/>
+                    <a:pt x="5954712" y="3823297"/>
+                  </a:cubicBezTo>
+                  <a:cubicBezTo>
+                    <a:pt x="6008052" y="3814407"/>
+                    <a:pt x="6046152" y="3820757"/>
+                    <a:pt x="6085522" y="3813137"/>
+                  </a:cubicBezTo>
+                  <a:cubicBezTo>
+                    <a:pt x="6118542" y="3806787"/>
+                    <a:pt x="6136322" y="3794087"/>
+                    <a:pt x="6175692" y="3787737"/>
+                  </a:cubicBezTo>
+                  <a:cubicBezTo>
+                    <a:pt x="6245542" y="3778847"/>
+                    <a:pt x="6392862" y="3791547"/>
+                    <a:pt x="6470332" y="3787737"/>
+                  </a:cubicBezTo>
+                  <a:cubicBezTo>
+                    <a:pt x="6519862" y="3785197"/>
+                    <a:pt x="6547802" y="3785197"/>
+                    <a:pt x="6593522" y="3776307"/>
+                  </a:cubicBezTo>
+                  <a:cubicBezTo>
+                    <a:pt x="6653212" y="3764877"/>
+                    <a:pt x="6724332" y="3726777"/>
+                    <a:pt x="6795452" y="3716617"/>
+                  </a:cubicBezTo>
+                  <a:cubicBezTo>
+                    <a:pt x="6871652" y="3705187"/>
+                    <a:pt x="6958012" y="3720427"/>
+                    <a:pt x="7039292" y="3714077"/>
+                  </a:cubicBezTo>
+                  <a:cubicBezTo>
+                    <a:pt x="7118032" y="3707727"/>
+                    <a:pt x="7191692" y="3687407"/>
+                    <a:pt x="7275512" y="3679787"/>
+                  </a:cubicBezTo>
+                  <a:cubicBezTo>
+                    <a:pt x="7368222" y="3670897"/>
+                    <a:pt x="7464742" y="3681057"/>
+                    <a:pt x="7575232" y="3667087"/>
+                  </a:cubicBezTo>
+                  <a:cubicBezTo>
+                    <a:pt x="7712392" y="3649307"/>
+                    <a:pt x="7923212" y="3584537"/>
+                    <a:pt x="8036242" y="3569297"/>
+                  </a:cubicBezTo>
+                  <a:cubicBezTo>
+                    <a:pt x="8099742" y="3559137"/>
+                    <a:pt x="8131492" y="3566757"/>
+                    <a:pt x="8188642" y="3556597"/>
+                  </a:cubicBezTo>
+                  <a:cubicBezTo>
+                    <a:pt x="8264842" y="3542627"/>
+                    <a:pt x="8351202" y="3505797"/>
+                    <a:pt x="8448992" y="3481667"/>
+                  </a:cubicBezTo>
+                  <a:cubicBezTo>
+                    <a:pt x="8575992" y="3452457"/>
+                    <a:pt x="8791892" y="3432137"/>
+                    <a:pt x="8888412" y="3400387"/>
+                  </a:cubicBezTo>
+                  <a:cubicBezTo>
+                    <a:pt x="8937942" y="3383877"/>
+                    <a:pt x="8954452" y="3359747"/>
+                    <a:pt x="8997632" y="3348317"/>
+                  </a:cubicBezTo>
+                  <a:cubicBezTo>
+                    <a:pt x="9050972" y="3334347"/>
+                    <a:pt x="9114472" y="3345777"/>
+                    <a:pt x="9190672" y="3334347"/>
+                  </a:cubicBezTo>
+                  <a:cubicBezTo>
+                    <a:pt x="9301162" y="3316567"/>
+                    <a:pt x="9509442" y="3245447"/>
+                    <a:pt x="9593262" y="3232747"/>
+                  </a:cubicBezTo>
+                  <a:cubicBezTo>
+                    <a:pt x="9630092" y="3226397"/>
+                    <a:pt x="9646602" y="3232747"/>
+                    <a:pt x="9674542" y="3226397"/>
+                  </a:cubicBezTo>
+                  <a:cubicBezTo>
+                    <a:pt x="9706292" y="3220047"/>
+                    <a:pt x="9736772" y="3207347"/>
+                    <a:pt x="9773602" y="3190837"/>
+                  </a:cubicBezTo>
+                  <a:cubicBezTo>
+                    <a:pt x="9821862" y="3170517"/>
+                    <a:pt x="9870122" y="3137497"/>
+                    <a:pt x="9937432" y="3108287"/>
+                  </a:cubicBezTo>
+                  <a:cubicBezTo>
+                    <a:pt x="10039032" y="3065107"/>
+                    <a:pt x="10242232" y="3007957"/>
+                    <a:pt x="10328592" y="2963507"/>
+                  </a:cubicBezTo>
+                  <a:cubicBezTo>
+                    <a:pt x="10375582" y="2940647"/>
+                    <a:pt x="10399712" y="2910167"/>
+                    <a:pt x="10432732" y="2896197"/>
+                  </a:cubicBezTo>
+                  <a:cubicBezTo>
+                    <a:pt x="10458132" y="2884767"/>
+                    <a:pt x="10484802" y="2892387"/>
+                    <a:pt x="10507662" y="2878417"/>
+                  </a:cubicBezTo>
+                  <a:cubicBezTo>
+                    <a:pt x="10535602" y="2860637"/>
+                    <a:pt x="10549572" y="2812377"/>
+                    <a:pt x="10578782" y="2785707"/>
+                  </a:cubicBezTo>
+                  <a:cubicBezTo>
+                    <a:pt x="10610532" y="2756497"/>
+                    <a:pt x="10648632" y="2738717"/>
+                    <a:pt x="10693082" y="2713317"/>
+                  </a:cubicBezTo>
+                  <a:cubicBezTo>
+                    <a:pt x="10752772" y="2677757"/>
+                    <a:pt x="10850562" y="2620607"/>
+                    <a:pt x="10910252" y="2595207"/>
+                  </a:cubicBezTo>
+                  <a:cubicBezTo>
+                    <a:pt x="10949622" y="2577427"/>
+                    <a:pt x="10986452" y="2579967"/>
+                    <a:pt x="11013122" y="2560917"/>
+                  </a:cubicBezTo>
+                  <a:cubicBezTo>
+                    <a:pt x="11035982" y="2544407"/>
+                    <a:pt x="11039792" y="2511387"/>
+                    <a:pt x="11063922" y="2492337"/>
+                  </a:cubicBezTo>
+                  <a:cubicBezTo>
+                    <a:pt x="11094402" y="2469477"/>
+                    <a:pt x="11152822" y="2461857"/>
+                    <a:pt x="11185842" y="2440267"/>
+                  </a:cubicBezTo>
+                  <a:cubicBezTo>
+                    <a:pt x="11215052" y="2422487"/>
+                    <a:pt x="11231562" y="2394547"/>
+                    <a:pt x="11258232" y="2378037"/>
+                  </a:cubicBezTo>
+                  <a:cubicBezTo>
+                    <a:pt x="11287442" y="2361527"/>
+                    <a:pt x="11325542" y="2360257"/>
+                    <a:pt x="11356022" y="2342477"/>
+                  </a:cubicBezTo>
+                  <a:cubicBezTo>
+                    <a:pt x="11387772" y="2324697"/>
+                    <a:pt x="11411902" y="2286597"/>
+                    <a:pt x="11444922" y="2267547"/>
+                  </a:cubicBezTo>
+                  <a:cubicBezTo>
+                    <a:pt x="11475402" y="2249767"/>
+                    <a:pt x="11512232" y="2249767"/>
+                    <a:pt x="11543982" y="2231987"/>
+                  </a:cubicBezTo>
+                  <a:cubicBezTo>
+                    <a:pt x="11580812" y="2212937"/>
+                    <a:pt x="11607482" y="2178647"/>
+                    <a:pt x="11650662" y="2157057"/>
+                  </a:cubicBezTo>
+                  <a:cubicBezTo>
+                    <a:pt x="11702732" y="2129117"/>
+                    <a:pt x="11795442" y="2112607"/>
+                    <a:pt x="11841162" y="2088477"/>
+                  </a:cubicBezTo>
+                  <a:cubicBezTo>
+                    <a:pt x="11869102" y="2074507"/>
+                    <a:pt x="11877992" y="2056727"/>
+                    <a:pt x="11905932" y="2045297"/>
+                  </a:cubicBezTo>
+                  <a:cubicBezTo>
+                    <a:pt x="11947842" y="2026247"/>
+                    <a:pt x="12008802" y="2023707"/>
+                    <a:pt x="12074842" y="2003387"/>
+                  </a:cubicBezTo>
+                  <a:cubicBezTo>
+                    <a:pt x="12173902" y="1971637"/>
+                    <a:pt x="12360592" y="1889087"/>
+                    <a:pt x="12443142" y="1861147"/>
+                  </a:cubicBezTo>
+                  <a:cubicBezTo>
+                    <a:pt x="12482512" y="1847177"/>
+                    <a:pt x="12500292" y="1840827"/>
+                    <a:pt x="12533312" y="1834477"/>
+                  </a:cubicBezTo>
+                  <a:cubicBezTo>
+                    <a:pt x="12573952" y="1826857"/>
+                    <a:pt x="12619672" y="1830667"/>
+                    <a:pt x="12669202" y="1821777"/>
+                  </a:cubicBezTo>
+                  <a:cubicBezTo>
+                    <a:pt x="12730162" y="1810347"/>
+                    <a:pt x="12787312" y="1777327"/>
+                    <a:pt x="12873672" y="1764627"/>
+                  </a:cubicBezTo>
+                  <a:cubicBezTo>
+                    <a:pt x="13012102" y="1745577"/>
+                    <a:pt x="13288962" y="1769707"/>
+                    <a:pt x="13423582" y="1757007"/>
+                  </a:cubicBezTo>
+                  <a:cubicBezTo>
+                    <a:pt x="13503593" y="1749387"/>
+                    <a:pt x="13522643" y="1732877"/>
+                    <a:pt x="13612812" y="1725257"/>
+                  </a:cubicBezTo>
+                  <a:cubicBezTo>
+                    <a:pt x="13836332" y="1706207"/>
+                    <a:pt x="14520862" y="1737957"/>
+                    <a:pt x="14786293" y="1718907"/>
+                  </a:cubicBezTo>
+                  <a:cubicBezTo>
+                    <a:pt x="14924721" y="1708747"/>
+                    <a:pt x="15006002" y="1693507"/>
+                    <a:pt x="15097443" y="1675727"/>
+                  </a:cubicBezTo>
+                  <a:cubicBezTo>
+                    <a:pt x="15173643" y="1661757"/>
+                    <a:pt x="15233332" y="1654137"/>
+                    <a:pt x="15303182" y="1628737"/>
+                  </a:cubicBezTo>
+                  <a:cubicBezTo>
+                    <a:pt x="15378112" y="1600797"/>
+                    <a:pt x="15461932" y="1563967"/>
+                    <a:pt x="15533052" y="1511897"/>
+                  </a:cubicBezTo>
+                  <a:cubicBezTo>
+                    <a:pt x="15607982" y="1454747"/>
+                    <a:pt x="15703232" y="1354417"/>
+                    <a:pt x="15736252" y="1294727"/>
+                  </a:cubicBezTo>
+                  <a:cubicBezTo>
+                    <a:pt x="15754032" y="1261707"/>
+                    <a:pt x="15747682" y="1233767"/>
+                    <a:pt x="15757843" y="1207097"/>
+                  </a:cubicBezTo>
+                  <a:cubicBezTo>
+                    <a:pt x="15768002" y="1181697"/>
+                    <a:pt x="15788321" y="1172807"/>
+                    <a:pt x="15797212" y="1138517"/>
+                  </a:cubicBezTo>
+                  <a:cubicBezTo>
+                    <a:pt x="15818802" y="1058507"/>
+                    <a:pt x="15811182" y="800697"/>
+                    <a:pt x="15794671" y="709257"/>
+                  </a:cubicBezTo>
+                  <a:cubicBezTo>
+                    <a:pt x="15787052" y="666077"/>
+                    <a:pt x="15779432" y="641947"/>
+                    <a:pt x="15760382" y="614007"/>
+                  </a:cubicBezTo>
+                  <a:cubicBezTo>
+                    <a:pt x="15740062" y="584797"/>
+                    <a:pt x="15714662" y="563207"/>
+                    <a:pt x="15674021" y="540347"/>
+                  </a:cubicBezTo>
+                  <a:cubicBezTo>
+                    <a:pt x="15599093" y="500977"/>
+                    <a:pt x="15501302" y="462877"/>
+                    <a:pt x="15327312" y="436207"/>
+                  </a:cubicBezTo>
+                  <a:cubicBezTo>
+                    <a:pt x="14848521" y="363817"/>
+                    <a:pt x="13408343" y="420967"/>
+                    <a:pt x="12553632" y="419697"/>
+                  </a:cubicBezTo>
+                  <a:cubicBezTo>
+                    <a:pt x="11818302" y="419697"/>
+                    <a:pt x="10806112" y="440017"/>
+                    <a:pt x="10505122" y="429857"/>
+                  </a:cubicBezTo>
+                  <a:cubicBezTo>
+                    <a:pt x="10418762" y="426047"/>
+                    <a:pt x="10407332" y="427317"/>
+                    <a:pt x="10340022" y="417157"/>
+                  </a:cubicBezTo>
+                  <a:cubicBezTo>
+                    <a:pt x="10229532" y="400647"/>
+                    <a:pt x="10074592" y="348577"/>
+                    <a:pt x="9906952" y="315557"/>
+                  </a:cubicBezTo>
+                  <a:cubicBezTo>
+                    <a:pt x="9677082" y="271107"/>
+                    <a:pt x="9367202" y="206337"/>
+                    <a:pt x="9087802" y="182207"/>
+                  </a:cubicBezTo>
+                  <a:cubicBezTo>
+                    <a:pt x="8798242" y="158077"/>
+                    <a:pt x="8619172" y="174587"/>
+                    <a:pt x="8200072" y="173317"/>
+                  </a:cubicBezTo>
+                  <a:cubicBezTo>
+                    <a:pt x="7185342" y="166967"/>
+                    <a:pt x="3734752" y="113627"/>
+                    <a:pt x="2982912" y="172047"/>
+                  </a:cubicBezTo>
+                  <a:cubicBezTo>
+                    <a:pt x="2774632" y="188557"/>
+                    <a:pt x="2692082" y="211417"/>
+                    <a:pt x="2585402" y="235547"/>
+                  </a:cubicBezTo>
+                  <a:cubicBezTo>
+                    <a:pt x="2511742" y="252057"/>
+                    <a:pt x="2476182" y="274917"/>
+                    <a:pt x="2399982" y="291427"/>
+                  </a:cubicBezTo>
+                  <a:cubicBezTo>
+                    <a:pt x="2285682" y="315557"/>
+                    <a:pt x="2073592" y="324447"/>
+                    <a:pt x="1959292" y="349847"/>
+                  </a:cubicBezTo>
+                  <a:cubicBezTo>
+                    <a:pt x="1883092" y="366357"/>
+                    <a:pt x="1834832" y="393027"/>
+                    <a:pt x="1773872" y="408267"/>
+                  </a:cubicBezTo>
+                  <a:cubicBezTo>
+                    <a:pt x="1716722" y="422237"/>
+                    <a:pt x="1662112" y="431127"/>
+                    <a:pt x="1602422" y="441287"/>
+                  </a:cubicBezTo>
+                  <a:cubicBezTo>
+                    <a:pt x="1537652" y="450177"/>
+                    <a:pt x="1476692" y="461607"/>
+                    <a:pt x="1400492" y="465417"/>
+                  </a:cubicBezTo>
+                  <a:cubicBezTo>
+                    <a:pt x="1298892" y="469227"/>
+                    <a:pt x="1096962" y="479387"/>
+                    <a:pt x="1044892" y="455257"/>
+                  </a:cubicBezTo>
+                  <a:cubicBezTo>
+                    <a:pt x="1025842" y="447637"/>
+                    <a:pt x="1019492" y="434937"/>
+                    <a:pt x="1014412" y="420967"/>
+                  </a:cubicBezTo>
+                  <a:cubicBezTo>
+                    <a:pt x="1009332" y="408267"/>
+                    <a:pt x="1010602" y="387947"/>
+                    <a:pt x="1014412" y="375247"/>
+                  </a:cubicBezTo>
+                  <a:cubicBezTo>
+                    <a:pt x="1018222" y="365087"/>
+                    <a:pt x="1023302" y="356197"/>
+                    <a:pt x="1032192" y="349847"/>
+                  </a:cubicBezTo>
+                  <a:cubicBezTo>
+                    <a:pt x="1042352" y="342227"/>
+                    <a:pt x="1075372" y="333337"/>
+                    <a:pt x="1075372" y="333337"/>
+                  </a:cubicBezTo>
+                </a:path>
+              </a:pathLst>
+            </a:custGeom>
+            <a:solidFill>
+              <a:srgbClr val="E7191F"/>
+            </a:solidFill>
+            <a:ln cap="sq">
+              <a:noFill/>
+              <a:prstDash val="solid"/>
+              <a:miter/>
+            </a:ln>
+          </p:spPr>
+        </p:sp>
+      </p:grpSp>
+    </p:spTree>
+  </p:cSld>
+  <p:clrMapOvr>
+    <a:masterClrMapping/>
+  </p:clrMapOvr>
+</p:sld>
+</file>
+
+<file path=ppt/slides/slide9.xml><?xml version="1.0" encoding="utf-8"?>
+<p:sld xmlns:p="http://schemas.openxmlformats.org/presentationml/2006/main" xmlns:a="http://schemas.openxmlformats.org/drawingml/2006/main" xmlns:r="http://schemas.openxmlformats.org/officeDocument/2006/relationships">
+  <p:cSld>
+    <p:spTree>
+      <p:nvGrpSpPr>
+        <p:cNvPr id="1" name=""/>
+        <p:cNvGrpSpPr/>
+        <p:nvPr/>
+      </p:nvGrpSpPr>
+      <p:grpSpPr>
+        <a:xfrm>
+          <a:off x="0" y="0"/>
+          <a:ext cx="0" cy="0"/>
+          <a:chOff x="0" y="0"/>
+          <a:chExt cx="0" cy="0"/>
+        </a:xfrm>
+      </p:grpSpPr>
+      <p:sp>
+        <p:nvSpPr>
+          <p:cNvPr name="Freeform 2" id="2"/>
+          <p:cNvSpPr/>
+          <p:nvPr/>
+        </p:nvSpPr>
+        <p:spPr>
+          <a:xfrm flipH="false" flipV="false" rot="0">
+            <a:off x="0" y="0"/>
+            <a:ext cx="18288000" cy="10287000"/>
+          </a:xfrm>
+          <a:custGeom>
+            <a:avLst/>
+            <a:gdLst/>
+            <a:ahLst/>
+            <a:cxnLst/>
+            <a:rect r="r" b="b" t="t" l="l"/>
+            <a:pathLst>
+              <a:path h="10287000" w="18288000">
+                <a:moveTo>
+                  <a:pt x="0" y="0"/>
+                </a:moveTo>
+                <a:lnTo>
+                  <a:pt x="18288000" y="0"/>
+                </a:lnTo>
+                <a:lnTo>
+                  <a:pt x="18288000" y="10287000"/>
+                </a:lnTo>
+                <a:lnTo>
+                  <a:pt x="0" y="10287000"/>
+                </a:lnTo>
+                <a:lnTo>
+                  <a:pt x="0" y="0"/>
+                </a:lnTo>
+                <a:close/>
+              </a:path>
+            </a:pathLst>
+          </a:custGeom>
+          <a:blipFill>
+            <a:blip r:embed="rId2"/>
+            <a:stretch>
+              <a:fillRect l="-8647" t="-18123" r="-6133" b="-85931"/>
+            </a:stretch>
+          </a:blipFill>
+        </p:spPr>
+      </p:sp>
+      <p:sp>
+        <p:nvSpPr>
+          <p:cNvPr name="Freeform 3" id="3" descr="Orange Blur Circle Illustration"/>
+          <p:cNvSpPr/>
+          <p:nvPr/>
+        </p:nvSpPr>
+        <p:spPr>
+          <a:xfrm flipH="false" flipV="false" rot="0">
+            <a:off x="15450107" y="-97052"/>
+            <a:ext cx="8883833" cy="8883833"/>
+          </a:xfrm>
+          <a:custGeom>
+            <a:avLst/>
+            <a:gdLst/>
+            <a:ahLst/>
+            <a:cxnLst/>
+            <a:rect r="r" b="b" t="t" l="l"/>
+            <a:pathLst>
+              <a:path h="8883833" w="8883833">
+                <a:moveTo>
+                  <a:pt x="0" y="0"/>
+                </a:moveTo>
+                <a:lnTo>
+                  <a:pt x="8883833" y="0"/>
+                </a:lnTo>
+                <a:lnTo>
+                  <a:pt x="8883833" y="8883833"/>
+                </a:lnTo>
+                <a:lnTo>
+                  <a:pt x="0" y="8883833"/>
+                </a:lnTo>
+                <a:lnTo>
+                  <a:pt x="0" y="0"/>
+                </a:lnTo>
+                <a:close/>
+              </a:path>
+            </a:pathLst>
+          </a:custGeom>
+          <a:blipFill>
+            <a:blip r:embed="rId3">
+              <a:alphaModFix amt="26000"/>
+              <a:extLst>
+                <a:ext uri="{96DAC541-7B7A-43D3-8B79-37D633B846F1}">
+                  <asvg:svgBlip xmlns:asvg="http://schemas.microsoft.com/office/drawing/2016/SVG/main" r:embed="rId4"/>
+                </a:ext>
+              </a:extLst>
+            </a:blip>
+            <a:stretch>
+              <a:fillRect l="0" t="0" r="0" b="0"/>
+            </a:stretch>
+          </a:blipFill>
+        </p:spPr>
+      </p:sp>
+      <p:sp>
+        <p:nvSpPr>
+          <p:cNvPr name="Freeform 4" id="4" descr="70's Groovy Wavy Pattern"/>
+          <p:cNvSpPr/>
+          <p:nvPr/>
+        </p:nvSpPr>
+        <p:spPr>
+          <a:xfrm flipH="false" flipV="false" rot="0">
+            <a:off x="0" y="56747"/>
+            <a:ext cx="8708490" cy="1141958"/>
+          </a:xfrm>
+          <a:custGeom>
+            <a:avLst/>
+            <a:gdLst/>
+            <a:ahLst/>
+            <a:cxnLst/>
+            <a:rect r="r" b="b" t="t" l="l"/>
+            <a:pathLst>
+              <a:path h="1141958" w="8708490">
+                <a:moveTo>
+                  <a:pt x="0" y="0"/>
+                </a:moveTo>
+                <a:lnTo>
+                  <a:pt x="8708490" y="0"/>
+                </a:lnTo>
+                <a:lnTo>
+                  <a:pt x="8708490" y="1141958"/>
+                </a:lnTo>
+                <a:lnTo>
+                  <a:pt x="0" y="1141958"/>
+                </a:lnTo>
+                <a:lnTo>
+                  <a:pt x="0" y="0"/>
+                </a:lnTo>
+                <a:close/>
+              </a:path>
+            </a:pathLst>
+          </a:custGeom>
+          <a:blipFill>
+            <a:blip r:embed="rId5">
+              <a:alphaModFix amt="9999"/>
+              <a:extLst>
+                <a:ext uri="{96DAC541-7B7A-43D3-8B79-37D633B846F1}">
+                  <asvg:svgBlip xmlns:asvg="http://schemas.microsoft.com/office/drawing/2016/SVG/main" r:embed="rId6"/>
+                </a:ext>
+              </a:extLst>
+            </a:blip>
+            <a:stretch>
+              <a:fillRect l="-1768" t="0" r="0" b="-680339"/>
+            </a:stretch>
+          </a:blipFill>
+        </p:spPr>
+      </p:sp>
+      <p:sp>
+        <p:nvSpPr>
+          <p:cNvPr name="Freeform 5" id="5" descr="Orange Blur Circle Illustration"/>
+          <p:cNvSpPr/>
+          <p:nvPr/>
+        </p:nvSpPr>
+        <p:spPr>
+          <a:xfrm flipH="false" flipV="false" rot="0">
+            <a:off x="-6049594" y="-97052"/>
+            <a:ext cx="8883833" cy="8883833"/>
+          </a:xfrm>
+          <a:custGeom>
+            <a:avLst/>
+            <a:gdLst/>
+            <a:ahLst/>
+            <a:cxnLst/>
+            <a:rect r="r" b="b" t="t" l="l"/>
+            <a:pathLst>
+              <a:path h="8883833" w="8883833">
+                <a:moveTo>
+                  <a:pt x="0" y="0"/>
+                </a:moveTo>
+                <a:lnTo>
+                  <a:pt x="8883833" y="0"/>
+                </a:lnTo>
+                <a:lnTo>
+                  <a:pt x="8883833" y="8883833"/>
+                </a:lnTo>
+                <a:lnTo>
+                  <a:pt x="0" y="8883833"/>
+                </a:lnTo>
+                <a:lnTo>
+                  <a:pt x="0" y="0"/>
+                </a:lnTo>
+                <a:close/>
+              </a:path>
+            </a:pathLst>
+          </a:custGeom>
+          <a:blipFill>
+            <a:blip r:embed="rId3">
+              <a:alphaModFix amt="26000"/>
+              <a:extLst>
+                <a:ext uri="{96DAC541-7B7A-43D3-8B79-37D633B846F1}">
+                  <asvg:svgBlip xmlns:asvg="http://schemas.microsoft.com/office/drawing/2016/SVG/main" r:embed="rId4"/>
+                </a:ext>
+              </a:extLst>
+            </a:blip>
+            <a:stretch>
+              <a:fillRect l="0" t="0" r="0" b="0"/>
+            </a:stretch>
+          </a:blipFill>
+        </p:spPr>
+      </p:sp>
+      <p:sp>
+        <p:nvSpPr>
+          <p:cNvPr name="Freeform 6" id="6"/>
+          <p:cNvSpPr/>
+          <p:nvPr/>
+        </p:nvSpPr>
+        <p:spPr>
+          <a:xfrm flipH="false" flipV="false" rot="-8291044">
+            <a:off x="14252994" y="-2820751"/>
+            <a:ext cx="7684417" cy="5907396"/>
+          </a:xfrm>
+          <a:custGeom>
+            <a:avLst/>
+            <a:gdLst/>
+            <a:ahLst/>
+            <a:cxnLst/>
+            <a:rect r="r" b="b" t="t" l="l"/>
+            <a:pathLst>
+              <a:path h="5907396" w="7684417">
+                <a:moveTo>
+                  <a:pt x="0" y="0"/>
+                </a:moveTo>
+                <a:lnTo>
+                  <a:pt x="7684418" y="0"/>
+                </a:lnTo>
+                <a:lnTo>
+                  <a:pt x="7684418" y="5907396"/>
+                </a:lnTo>
+                <a:lnTo>
+                  <a:pt x="0" y="5907396"/>
+                </a:lnTo>
+                <a:lnTo>
+                  <a:pt x="0" y="0"/>
+                </a:lnTo>
+                <a:close/>
+              </a:path>
+            </a:pathLst>
+          </a:custGeom>
+          <a:blipFill>
+            <a:blip r:embed="rId7"/>
+            <a:stretch>
+              <a:fillRect l="0" t="0" r="0" b="0"/>
+            </a:stretch>
+          </a:blipFill>
+        </p:spPr>
+      </p:sp>
+      <p:grpSp>
+        <p:nvGrpSpPr>
+          <p:cNvPr name="Group 7" id="7"/>
+          <p:cNvGrpSpPr/>
+          <p:nvPr/>
+        </p:nvGrpSpPr>
+        <p:grpSpPr>
+          <a:xfrm rot="0">
             <a:off x="-356199" y="-439305"/>
             <a:ext cx="15806306" cy="8206101"/>
             <a:chOff x="0" y="0"/>
@@ -10965,651 +12065,6 @@
                 </a:lnTo>
                 <a:lnTo>
                   <a:pt x="19702880" y="9921734"/>
-                </a:lnTo>
-                <a:lnTo>
-                  <a:pt x="0" y="9921734"/>
-                </a:lnTo>
-                <a:lnTo>
-                  <a:pt x="0" y="0"/>
-                </a:lnTo>
-                <a:close/>
-              </a:path>
-            </a:pathLst>
-          </a:custGeom>
-          <a:blipFill>
-            <a:blip r:embed="rId9"/>
-            <a:stretch>
-              <a:fillRect l="-16615" t="-37522" r="-15759" b="0"/>
-            </a:stretch>
-          </a:blipFill>
-        </p:spPr>
-      </p:sp>
-    </p:spTree>
-  </p:cSld>
-  <p:clrMapOvr>
-    <a:masterClrMapping/>
-  </p:clrMapOvr>
-</p:sld>
-</file>
-
-<file path=ppt/slides/slide9.xml><?xml version="1.0" encoding="utf-8"?>
-<p:sld xmlns:p="http://schemas.openxmlformats.org/presentationml/2006/main" xmlns:a="http://schemas.openxmlformats.org/drawingml/2006/main" xmlns:r="http://schemas.openxmlformats.org/officeDocument/2006/relationships">
-  <p:cSld>
-    <p:spTree>
-      <p:nvGrpSpPr>
-        <p:cNvPr id="1" name=""/>
-        <p:cNvGrpSpPr/>
-        <p:nvPr/>
-      </p:nvGrpSpPr>
-      <p:grpSpPr>
-        <a:xfrm>
-          <a:off x="0" y="0"/>
-          <a:ext cx="0" cy="0"/>
-          <a:chOff x="0" y="0"/>
-          <a:chExt cx="0" cy="0"/>
-        </a:xfrm>
-      </p:grpSpPr>
-      <p:sp>
-        <p:nvSpPr>
-          <p:cNvPr name="Freeform 2" id="2"/>
-          <p:cNvSpPr/>
-          <p:nvPr/>
-        </p:nvSpPr>
-        <p:spPr>
-          <a:xfrm flipH="false" flipV="false" rot="0">
-            <a:off x="0" y="0"/>
-            <a:ext cx="18288000" cy="10287000"/>
-          </a:xfrm>
-          <a:custGeom>
-            <a:avLst/>
-            <a:gdLst/>
-            <a:ahLst/>
-            <a:cxnLst/>
-            <a:rect r="r" b="b" t="t" l="l"/>
-            <a:pathLst>
-              <a:path h="10287000" w="18288000">
-                <a:moveTo>
-                  <a:pt x="0" y="0"/>
-                </a:moveTo>
-                <a:lnTo>
-                  <a:pt x="18288000" y="0"/>
-                </a:lnTo>
-                <a:lnTo>
-                  <a:pt x="18288000" y="10287000"/>
-                </a:lnTo>
-                <a:lnTo>
-                  <a:pt x="0" y="10287000"/>
-                </a:lnTo>
-                <a:lnTo>
-                  <a:pt x="0" y="0"/>
-                </a:lnTo>
-                <a:close/>
-              </a:path>
-            </a:pathLst>
-          </a:custGeom>
-          <a:blipFill>
-            <a:blip r:embed="rId2"/>
-            <a:stretch>
-              <a:fillRect l="-8647" t="-18123" r="-6133" b="-85931"/>
-            </a:stretch>
-          </a:blipFill>
-        </p:spPr>
-      </p:sp>
-      <p:sp>
-        <p:nvSpPr>
-          <p:cNvPr name="Freeform 3" id="3" descr="Orange Blur Circle Illustration"/>
-          <p:cNvSpPr/>
-          <p:nvPr/>
-        </p:nvSpPr>
-        <p:spPr>
-          <a:xfrm flipH="false" flipV="false" rot="0">
-            <a:off x="15450107" y="-97052"/>
-            <a:ext cx="8883833" cy="8883833"/>
-          </a:xfrm>
-          <a:custGeom>
-            <a:avLst/>
-            <a:gdLst/>
-            <a:ahLst/>
-            <a:cxnLst/>
-            <a:rect r="r" b="b" t="t" l="l"/>
-            <a:pathLst>
-              <a:path h="8883833" w="8883833">
-                <a:moveTo>
-                  <a:pt x="0" y="0"/>
-                </a:moveTo>
-                <a:lnTo>
-                  <a:pt x="8883833" y="0"/>
-                </a:lnTo>
-                <a:lnTo>
-                  <a:pt x="8883833" y="8883833"/>
-                </a:lnTo>
-                <a:lnTo>
-                  <a:pt x="0" y="8883833"/>
-                </a:lnTo>
-                <a:lnTo>
-                  <a:pt x="0" y="0"/>
-                </a:lnTo>
-                <a:close/>
-              </a:path>
-            </a:pathLst>
-          </a:custGeom>
-          <a:blipFill>
-            <a:blip r:embed="rId3">
-              <a:alphaModFix amt="26000"/>
-              <a:extLst>
-                <a:ext uri="{96DAC541-7B7A-43D3-8B79-37D633B846F1}">
-                  <asvg:svgBlip xmlns:asvg="http://schemas.microsoft.com/office/drawing/2016/SVG/main" r:embed="rId4"/>
-                </a:ext>
-              </a:extLst>
-            </a:blip>
-            <a:stretch>
-              <a:fillRect l="0" t="0" r="0" b="0"/>
-            </a:stretch>
-          </a:blipFill>
-        </p:spPr>
-      </p:sp>
-      <p:sp>
-        <p:nvSpPr>
-          <p:cNvPr name="Freeform 4" id="4" descr="70's Groovy Wavy Pattern"/>
-          <p:cNvSpPr/>
-          <p:nvPr/>
-        </p:nvSpPr>
-        <p:spPr>
-          <a:xfrm flipH="false" flipV="false" rot="0">
-            <a:off x="0" y="56747"/>
-            <a:ext cx="8708490" cy="1141958"/>
-          </a:xfrm>
-          <a:custGeom>
-            <a:avLst/>
-            <a:gdLst/>
-            <a:ahLst/>
-            <a:cxnLst/>
-            <a:rect r="r" b="b" t="t" l="l"/>
-            <a:pathLst>
-              <a:path h="1141958" w="8708490">
-                <a:moveTo>
-                  <a:pt x="0" y="0"/>
-                </a:moveTo>
-                <a:lnTo>
-                  <a:pt x="8708490" y="0"/>
-                </a:lnTo>
-                <a:lnTo>
-                  <a:pt x="8708490" y="1141958"/>
-                </a:lnTo>
-                <a:lnTo>
-                  <a:pt x="0" y="1141958"/>
-                </a:lnTo>
-                <a:lnTo>
-                  <a:pt x="0" y="0"/>
-                </a:lnTo>
-                <a:close/>
-              </a:path>
-            </a:pathLst>
-          </a:custGeom>
-          <a:blipFill>
-            <a:blip r:embed="rId5">
-              <a:alphaModFix amt="9999"/>
-              <a:extLst>
-                <a:ext uri="{96DAC541-7B7A-43D3-8B79-37D633B846F1}">
-                  <asvg:svgBlip xmlns:asvg="http://schemas.microsoft.com/office/drawing/2016/SVG/main" r:embed="rId6"/>
-                </a:ext>
-              </a:extLst>
-            </a:blip>
-            <a:stretch>
-              <a:fillRect l="-1768" t="0" r="0" b="-680339"/>
-            </a:stretch>
-          </a:blipFill>
-        </p:spPr>
-      </p:sp>
-      <p:sp>
-        <p:nvSpPr>
-          <p:cNvPr name="Freeform 5" id="5" descr="Orange Blur Circle Illustration"/>
-          <p:cNvSpPr/>
-          <p:nvPr/>
-        </p:nvSpPr>
-        <p:spPr>
-          <a:xfrm flipH="false" flipV="false" rot="0">
-            <a:off x="-6049594" y="-97052"/>
-            <a:ext cx="8883833" cy="8883833"/>
-          </a:xfrm>
-          <a:custGeom>
-            <a:avLst/>
-            <a:gdLst/>
-            <a:ahLst/>
-            <a:cxnLst/>
-            <a:rect r="r" b="b" t="t" l="l"/>
-            <a:pathLst>
-              <a:path h="8883833" w="8883833">
-                <a:moveTo>
-                  <a:pt x="0" y="0"/>
-                </a:moveTo>
-                <a:lnTo>
-                  <a:pt x="8883833" y="0"/>
-                </a:lnTo>
-                <a:lnTo>
-                  <a:pt x="8883833" y="8883833"/>
-                </a:lnTo>
-                <a:lnTo>
-                  <a:pt x="0" y="8883833"/>
-                </a:lnTo>
-                <a:lnTo>
-                  <a:pt x="0" y="0"/>
-                </a:lnTo>
-                <a:close/>
-              </a:path>
-            </a:pathLst>
-          </a:custGeom>
-          <a:blipFill>
-            <a:blip r:embed="rId3">
-              <a:alphaModFix amt="26000"/>
-              <a:extLst>
-                <a:ext uri="{96DAC541-7B7A-43D3-8B79-37D633B846F1}">
-                  <asvg:svgBlip xmlns:asvg="http://schemas.microsoft.com/office/drawing/2016/SVG/main" r:embed="rId4"/>
-                </a:ext>
-              </a:extLst>
-            </a:blip>
-            <a:stretch>
-              <a:fillRect l="0" t="0" r="0" b="0"/>
-            </a:stretch>
-          </a:blipFill>
-        </p:spPr>
-      </p:sp>
-      <p:sp>
-        <p:nvSpPr>
-          <p:cNvPr name="Freeform 6" id="6"/>
-          <p:cNvSpPr/>
-          <p:nvPr/>
-        </p:nvSpPr>
-        <p:spPr>
-          <a:xfrm flipH="false" flipV="false" rot="-8291044">
-            <a:off x="14252994" y="-2820751"/>
-            <a:ext cx="7684417" cy="5907396"/>
-          </a:xfrm>
-          <a:custGeom>
-            <a:avLst/>
-            <a:gdLst/>
-            <a:ahLst/>
-            <a:cxnLst/>
-            <a:rect r="r" b="b" t="t" l="l"/>
-            <a:pathLst>
-              <a:path h="5907396" w="7684417">
-                <a:moveTo>
-                  <a:pt x="0" y="0"/>
-                </a:moveTo>
-                <a:lnTo>
-                  <a:pt x="7684418" y="0"/>
-                </a:lnTo>
-                <a:lnTo>
-                  <a:pt x="7684418" y="5907396"/>
-                </a:lnTo>
-                <a:lnTo>
-                  <a:pt x="0" y="5907396"/>
-                </a:lnTo>
-                <a:lnTo>
-                  <a:pt x="0" y="0"/>
-                </a:lnTo>
-                <a:close/>
-              </a:path>
-            </a:pathLst>
-          </a:custGeom>
-          <a:blipFill>
-            <a:blip r:embed="rId7"/>
-            <a:stretch>
-              <a:fillRect l="0" t="0" r="0" b="0"/>
-            </a:stretch>
-          </a:blipFill>
-        </p:spPr>
-      </p:sp>
-      <p:grpSp>
-        <p:nvGrpSpPr>
-          <p:cNvPr name="Group 7" id="7"/>
-          <p:cNvGrpSpPr/>
-          <p:nvPr/>
-        </p:nvGrpSpPr>
-        <p:grpSpPr>
-          <a:xfrm rot="0">
-            <a:off x="-28575" y="-144677"/>
-            <a:ext cx="16574915" cy="9445770"/>
-            <a:chOff x="0" y="0"/>
-            <a:chExt cx="22099887" cy="12594360"/>
-          </a:xfrm>
-        </p:grpSpPr>
-        <p:pic>
-          <p:nvPicPr>
-            <p:cNvPr name="Picture 8" id="8"/>
-            <p:cNvPicPr>
-              <a:picLocks noChangeAspect="true"/>
-            </p:cNvPicPr>
-            <p:nvPr/>
-          </p:nvPicPr>
-          <p:blipFill>
-            <a:blip r:embed="rId8"/>
-            <a:srcRect l="0" t="3437" r="0" b="3437"/>
-            <a:stretch>
-              <a:fillRect/>
-            </a:stretch>
-          </p:blipFill>
-          <p:spPr>
-            <a:xfrm flipH="false" flipV="false">
-              <a:off x="0" y="0"/>
-              <a:ext cx="22099887" cy="12594360"/>
-            </a:xfrm>
-            <a:prstGeom prst="rect">
-              <a:avLst/>
-            </a:prstGeom>
-          </p:spPr>
-        </p:pic>
-      </p:grpSp>
-      <p:sp>
-        <p:nvSpPr>
-          <p:cNvPr name="Freeform 9" id="9"/>
-          <p:cNvSpPr/>
-          <p:nvPr/>
-        </p:nvSpPr>
-        <p:spPr>
-          <a:xfrm flipH="false" flipV="false" rot="0">
-            <a:off x="-1607678" y="-4352204"/>
-            <a:ext cx="19702881" cy="4713230"/>
-          </a:xfrm>
-          <a:custGeom>
-            <a:avLst/>
-            <a:gdLst/>
-            <a:ahLst/>
-            <a:cxnLst/>
-            <a:rect r="r" b="b" t="t" l="l"/>
-            <a:pathLst>
-              <a:path h="4713230" w="19702881">
-                <a:moveTo>
-                  <a:pt x="0" y="0"/>
-                </a:moveTo>
-                <a:lnTo>
-                  <a:pt x="19702881" y="0"/>
-                </a:lnTo>
-                <a:lnTo>
-                  <a:pt x="19702881" y="4713230"/>
-                </a:lnTo>
-                <a:lnTo>
-                  <a:pt x="0" y="4713230"/>
-                </a:lnTo>
-                <a:lnTo>
-                  <a:pt x="0" y="0"/>
-                </a:lnTo>
-                <a:close/>
-              </a:path>
-            </a:pathLst>
-          </a:custGeom>
-          <a:blipFill>
-            <a:blip r:embed="rId9"/>
-            <a:stretch>
-              <a:fillRect l="-650" t="-60057" r="0" b="-60057"/>
-            </a:stretch>
-          </a:blipFill>
-        </p:spPr>
-      </p:sp>
-      <p:sp>
-        <p:nvSpPr>
-          <p:cNvPr name="Freeform 10" id="10"/>
-          <p:cNvSpPr/>
-          <p:nvPr/>
-        </p:nvSpPr>
-        <p:spPr>
-          <a:xfrm flipH="false" flipV="false" rot="0">
-            <a:off x="14941755" y="-64804"/>
-            <a:ext cx="19702881" cy="9921734"/>
-          </a:xfrm>
-          <a:custGeom>
-            <a:avLst/>
-            <a:gdLst/>
-            <a:ahLst/>
-            <a:cxnLst/>
-            <a:rect r="r" b="b" t="t" l="l"/>
-            <a:pathLst>
-              <a:path h="9921734" w="19702881">
-                <a:moveTo>
-                  <a:pt x="0" y="0"/>
-                </a:moveTo>
-                <a:lnTo>
-                  <a:pt x="19702880" y="0"/>
-                </a:lnTo>
-                <a:lnTo>
-                  <a:pt x="19702880" y="9921735"/>
-                </a:lnTo>
-                <a:lnTo>
-                  <a:pt x="0" y="9921735"/>
-                </a:lnTo>
-                <a:lnTo>
-                  <a:pt x="0" y="0"/>
-                </a:lnTo>
-                <a:close/>
-              </a:path>
-            </a:pathLst>
-          </a:custGeom>
-          <a:blipFill>
-            <a:blip r:embed="rId9"/>
-            <a:stretch>
-              <a:fillRect l="-16615" t="-37522" r="-15759" b="0"/>
-            </a:stretch>
-          </a:blipFill>
-        </p:spPr>
-      </p:sp>
-      <p:sp>
-        <p:nvSpPr>
-          <p:cNvPr name="TextBox 11" id="11"/>
-          <p:cNvSpPr txBox="true"/>
-          <p:nvPr/>
-        </p:nvSpPr>
-        <p:spPr>
-          <a:xfrm rot="0">
-            <a:off x="9435193" y="2007081"/>
-            <a:ext cx="8951203" cy="7849850"/>
-          </a:xfrm>
-          <a:prstGeom prst="rect">
-            <a:avLst/>
-          </a:prstGeom>
-        </p:spPr>
-        <p:txBody>
-          <a:bodyPr anchor="t" rtlCol="false" tIns="0" lIns="0" bIns="0" rIns="0">
-            <a:spAutoFit/>
-          </a:bodyPr>
-          <a:lstStyle/>
-          <a:p>
-            <a:pPr algn="l">
-              <a:lnSpc>
-                <a:spcPts val="3896"/>
-              </a:lnSpc>
-            </a:pPr>
-            <a:r>
-              <a:rPr lang="en-US" sz="2597" b="true">
-                <a:solidFill>
-                  <a:srgbClr val="FFFFFF"/>
-                </a:solidFill>
-                <a:latin typeface="Garet Bold"/>
-                <a:ea typeface="Garet Bold"/>
-                <a:cs typeface="Garet Bold"/>
-                <a:sym typeface="Garet Bold"/>
-              </a:rPr>
-              <a:t>          Conferindo se o jogo foi ganho na horizontal:</a:t>
-            </a:r>
-          </a:p>
-          <a:p>
-            <a:pPr algn="l" marL="560824" indent="-280412" lvl="1">
-              <a:lnSpc>
-                <a:spcPts val="3896"/>
-              </a:lnSpc>
-              <a:buFont typeface="Arial"/>
-              <a:buChar char="•"/>
-            </a:pPr>
-            <a:r>
-              <a:rPr lang="en-US" b="true" sz="2597">
-                <a:solidFill>
-                  <a:srgbClr val="FFFFFF"/>
-                </a:solidFill>
-                <a:latin typeface="Garet Bold"/>
-                <a:ea typeface="Garet Bold"/>
-                <a:cs typeface="Garet Bold"/>
-                <a:sym typeface="Garet Bold"/>
-              </a:rPr>
-              <a:t>Inicializa com “count = 0”</a:t>
-            </a:r>
-          </a:p>
-          <a:p>
-            <a:pPr algn="l" marL="560824" indent="-280412" lvl="1">
-              <a:lnSpc>
-                <a:spcPts val="3896"/>
-              </a:lnSpc>
-              <a:buFont typeface="Arial"/>
-              <a:buChar char="•"/>
-            </a:pPr>
-            <a:r>
-              <a:rPr lang="en-US" b="true" sz="2597">
-                <a:solidFill>
-                  <a:srgbClr val="FFFFFF"/>
-                </a:solidFill>
-                <a:latin typeface="Garet Bold"/>
-                <a:ea typeface="Garet Bold"/>
-                <a:cs typeface="Garet Bold"/>
-                <a:sym typeface="Garet Bold"/>
-              </a:rPr>
-              <a:t>Se o número de “count” for do tamanho da matriz na horizontal, significa que o jogo foi ganho e encerra o loop 1</a:t>
-            </a:r>
-          </a:p>
-          <a:p>
-            <a:pPr algn="l" marL="560824" indent="-280412" lvl="1">
-              <a:lnSpc>
-                <a:spcPts val="3896"/>
-              </a:lnSpc>
-              <a:buFont typeface="Arial"/>
-              <a:buChar char="•"/>
-            </a:pPr>
-            <a:r>
-              <a:rPr lang="en-US" b="true" sz="2597">
-                <a:solidFill>
-                  <a:srgbClr val="FFFFFF"/>
-                </a:solidFill>
-                <a:latin typeface="Garet Bold"/>
-                <a:ea typeface="Garet Bold"/>
-                <a:cs typeface="Garet Bold"/>
-                <a:sym typeface="Garet Bold"/>
-              </a:rPr>
-              <a:t>Senão, inicia novamente “count” com zero e entra no segundo “for”</a:t>
-            </a:r>
-          </a:p>
-          <a:p>
-            <a:pPr algn="l" marL="560824" indent="-280412" lvl="1">
-              <a:lnSpc>
-                <a:spcPts val="3896"/>
-              </a:lnSpc>
-              <a:buFont typeface="Arial"/>
-              <a:buChar char="•"/>
-            </a:pPr>
-            <a:r>
-              <a:rPr lang="en-US" b="true" sz="2597">
-                <a:solidFill>
-                  <a:srgbClr val="FFFFFF"/>
-                </a:solidFill>
-                <a:latin typeface="Garet Bold"/>
-                <a:ea typeface="Garet Bold"/>
-                <a:cs typeface="Garet Bold"/>
-                <a:sym typeface="Garet Bold"/>
-              </a:rPr>
-              <a:t>Enquanto existir o “num” dentro da matriz, acrescenta +1 em “count”</a:t>
-            </a:r>
-          </a:p>
-          <a:p>
-            <a:pPr algn="l" marL="560824" indent="-280412" lvl="1">
-              <a:lnSpc>
-                <a:spcPts val="3896"/>
-              </a:lnSpc>
-              <a:buFont typeface="Arial"/>
-              <a:buChar char="•"/>
-            </a:pPr>
-            <a:r>
-              <a:rPr lang="en-US" b="true" sz="2597">
-                <a:solidFill>
-                  <a:srgbClr val="FFFFFF"/>
-                </a:solidFill>
-                <a:latin typeface="Garet Bold"/>
-                <a:ea typeface="Garet Bold"/>
-                <a:cs typeface="Garet Bold"/>
-                <a:sym typeface="Garet Bold"/>
-              </a:rPr>
-              <a:t>Se pular para a segunda linha da matriz e “count” for do tamanho da matriz, então o jogo foi ganho</a:t>
-            </a:r>
-          </a:p>
-          <a:p>
-            <a:pPr algn="l" marL="560824" indent="-280412" lvl="1">
-              <a:lnSpc>
-                <a:spcPts val="3896"/>
-              </a:lnSpc>
-              <a:buFont typeface="Arial"/>
-              <a:buChar char="•"/>
-            </a:pPr>
-            <a:r>
-              <a:rPr lang="en-US" b="true" sz="2597">
-                <a:solidFill>
-                  <a:srgbClr val="FFFFFF"/>
-                </a:solidFill>
-                <a:latin typeface="Garet Bold"/>
-                <a:ea typeface="Garet Bold"/>
-                <a:cs typeface="Garet Bold"/>
-                <a:sym typeface="Garet Bold"/>
-              </a:rPr>
-              <a:t>Se “count” não for do tamanho da matriz, “count” volta a ser zero e reinicia a contagem</a:t>
-            </a:r>
-          </a:p>
-          <a:p>
-            <a:pPr algn="l" marL="560824" indent="-280412" lvl="1">
-              <a:lnSpc>
-                <a:spcPts val="3896"/>
-              </a:lnSpc>
-              <a:spcBef>
-                <a:spcPct val="0"/>
-              </a:spcBef>
-              <a:buFont typeface="Arial"/>
-              <a:buChar char="•"/>
-            </a:pPr>
-            <a:r>
-              <a:rPr lang="en-US" b="true" sz="2597">
-                <a:solidFill>
-                  <a:srgbClr val="FFFFFF"/>
-                </a:solidFill>
-                <a:latin typeface="Garet Bold"/>
-                <a:ea typeface="Garet Bold"/>
-                <a:cs typeface="Garet Bold"/>
-                <a:sym typeface="Garet Bold"/>
-              </a:rPr>
-              <a:t>retorna true ou false para indicar se o jogo encerrou</a:t>
-            </a:r>
-          </a:p>
-        </p:txBody>
-      </p:sp>
-      <p:sp>
-        <p:nvSpPr>
-          <p:cNvPr name="Freeform 12" id="12"/>
-          <p:cNvSpPr/>
-          <p:nvPr/>
-        </p:nvSpPr>
-        <p:spPr>
-          <a:xfrm flipH="false" flipV="false" rot="0">
-            <a:off x="-1414881" y="8896479"/>
-            <a:ext cx="19702881" cy="9921734"/>
-          </a:xfrm>
-          <a:custGeom>
-            <a:avLst/>
-            <a:gdLst/>
-            <a:ahLst/>
-            <a:cxnLst/>
-            <a:rect r="r" b="b" t="t" l="l"/>
-            <a:pathLst>
-              <a:path h="9921734" w="19702881">
-                <a:moveTo>
-                  <a:pt x="0" y="0"/>
-                </a:moveTo>
-                <a:lnTo>
-                  <a:pt x="19702881" y="0"/>
-                </a:lnTo>
-                <a:lnTo>
-                  <a:pt x="19702881" y="9921734"/>
                 </a:lnTo>
                 <a:lnTo>
                   <a:pt x="0" y="9921734"/>

</xml_diff>